<commit_message>
Update HackSprint PPTX: Set name to Manjusha Varikuppala, team to Hackhustlers, added visual flowcharts and DFD
</commit_message>
<xml_diff>
--- a/HackSprint_Decision_Completeness_Engine.pptx
+++ b/HackSprint_Decision_Completeness_Engine.pptx
@@ -12775,8 +12775,8 @@
         </p:nvSpPr>
         <p:spPr>
           <a:xfrm>
-            <a:off x="1371600" y="6523502"/>
-            <a:ext cx="10058400" cy="2011680"/>
+            <a:off x="1371600" y="6217920"/>
+            <a:ext cx="10241280" cy="2286000"/>
           </a:xfrm>
           <a:prstGeom prst="rect">
             <a:avLst/>
@@ -12805,22 +12805,22 @@
               <a:buNone/>
             </a:pPr>
             <a:r>
-              <a:rPr sz="1500" b="1">
+              <a:rPr sz="1600" b="1">
                 <a:solidFill>
                   <a:srgbClr val="0F172A"/>
                 </a:solidFill>
                 <a:latin typeface="Playfair Display"/>
               </a:rPr>
-              <a:t>YOUR NAME: </a:t>
-            </a:r>
-            <a:r>
-              <a:rPr sz="1500" b="1">
+              <a:t>NAME: </a:t>
+            </a:r>
+            <a:r>
+              <a:rPr sz="1600" b="1">
                 <a:solidFill>
                   <a:srgbClr val="0F172A"/>
                 </a:solidFill>
                 <a:latin typeface="Calibri"/>
               </a:rPr>
-              <a:t>[Your Name(s)]</a:t>
+              <a:t>Manjusha Varikuppala</a:t>
             </a:r>
             <a:endParaRPr/>
           </a:p>
@@ -12831,7 +12831,7 @@
               </a:spcAft>
             </a:pPr>
             <a:r>
-              <a:rPr sz="1500" b="1">
+              <a:rPr sz="1600" b="1">
                 <a:solidFill>
                   <a:srgbClr val="0F172A"/>
                 </a:solidFill>
@@ -12840,13 +12840,13 @@
               <a:t>TEAM NAME: </a:t>
             </a:r>
             <a:r>
-              <a:rPr sz="1500" b="1">
-                <a:solidFill>
-                  <a:srgbClr val="0F172A"/>
+              <a:rPr sz="1600" b="1">
+                <a:solidFill>
+                  <a:srgbClr val="4F46E5"/>
                 </a:solidFill>
                 <a:latin typeface="Calibri"/>
               </a:rPr>
-              <a:t>The Completeness Crew</a:t>
+              <a:t>Hackhustlers</a:t>
             </a:r>
           </a:p>
           <a:p>
@@ -12856,22 +12856,22 @@
               </a:spcAft>
             </a:pPr>
             <a:r>
-              <a:rPr sz="1500" b="1">
+              <a:rPr sz="1600" b="1">
                 <a:solidFill>
                   <a:srgbClr val="0F172A"/>
                 </a:solidFill>
                 <a:latin typeface="Playfair Display"/>
               </a:rPr>
-              <a:t>TRACK NO: </a:t>
-            </a:r>
-            <a:r>
-              <a:rPr sz="1500" b="1">
+              <a:t>TRACK: </a:t>
+            </a:r>
+            <a:r>
+              <a:rPr sz="1600" b="1">
                 <a:solidFill>
                   <a:srgbClr val="0F172A"/>
                 </a:solidFill>
                 <a:latin typeface="Calibri"/>
               </a:rPr>
-              <a:t>AI &amp; Enterprise Automation (Open Innovation)</a:t>
+              <a:t>Track 01: AI &amp; Enterprise Automation (Open Innovation)</a:t>
             </a:r>
           </a:p>
           <a:p>
@@ -12881,7 +12881,7 @@
               </a:spcAft>
             </a:pPr>
             <a:r>
-              <a:rPr sz="1500" b="1">
+              <a:rPr sz="1600" b="1">
                 <a:solidFill>
                   <a:srgbClr val="0F172A"/>
                 </a:solidFill>
@@ -12890,7 +12890,7 @@
               <a:t>PROJECT: </a:t>
             </a:r>
             <a:r>
-              <a:rPr sz="1500" b="1">
+              <a:rPr sz="1600" b="1">
                 <a:solidFill>
                   <a:srgbClr val="0D9488"/>
                 </a:solidFill>
@@ -12906,7 +12906,7 @@
               </a:spcAft>
             </a:pPr>
             <a:r>
-              <a:rPr sz="1500" b="1">
+              <a:rPr sz="1600" b="1">
                 <a:solidFill>
                   <a:srgbClr val="0F172A"/>
                 </a:solidFill>
@@ -12915,9 +12915,9 @@
               <a:t>LIVE DEMO: </a:t>
             </a:r>
             <a:r>
-              <a:rPr sz="1500" b="0">
-                <a:solidFill>
-                  <a:srgbClr val="4F46E5"/>
+              <a:rPr sz="1600" b="0">
+                <a:solidFill>
+                  <a:srgbClr val="0F172A"/>
                 </a:solidFill>
                 <a:latin typeface="Calibri"/>
               </a:rPr>
@@ -13117,7 +13117,7 @@
           </a:solidFill>
           <a:ln w="19050">
             <a:solidFill>
-              <a:srgbClr val="CBD5E1"/>
+              <a:srgbClr val="FCA5A5"/>
             </a:solidFill>
           </a:ln>
         </p:spPr>
@@ -13136,14 +13136,14 @@
           </a:fontRef>
         </p:style>
         <p:txBody>
-          <a:bodyPr rtlCol="0" anchor="t" lIns="365760" rIns="365760" tIns="365760" bIns="365760" wrap="square"/>
+          <a:bodyPr rtlCol="0" anchor="ctr" lIns="365760" rIns="365760" tIns="320040"/>
           <a:lstStyle/>
           <a:p>
             <a:pPr algn="ctr">
               <a:spcAft>
-                <a:spcPts val="600"/>
-              </a:spcAft>
-              <a:defRPr sz="2000" b="1">
+                <a:spcPts val="1400"/>
+              </a:spcAft>
+              <a:defRPr sz="1800" b="1">
                 <a:solidFill>
                   <a:srgbClr val="DC2626"/>
                 </a:solidFill>
@@ -13151,119 +13151,7 @@
               </a:defRPr>
             </a:pPr>
             <a:r>
-              <a:t>THE PROBLEM WE SOLVE</a:t>
-            </a:r>
-          </a:p>
-          <a:p>
-            <a:pPr>
-              <a:spcAft>
-                <a:spcPts val="1600"/>
-              </a:spcAft>
-              <a:defRPr sz="1300" i="1">
-                <a:solidFill>
-                  <a:srgbClr val="64748B"/>
-                </a:solidFill>
-                <a:latin typeface="Calibri"/>
-              </a:defRPr>
-            </a:pPr>
-            <a:r>
-              <a:t>Traditional enterprise decision-making &amp; standard AI suffer from three fatal flaws:</a:t>
-            </a:r>
-          </a:p>
-          <a:p>
-            <a:pPr>
-              <a:spcAft>
-                <a:spcPts val="300"/>
-              </a:spcAft>
-              <a:defRPr sz="1500" b="1">
-                <a:solidFill>
-                  <a:srgbClr val="1E293B"/>
-                </a:solidFill>
-                <a:latin typeface="Calibri"/>
-              </a:defRPr>
-            </a:pPr>
-            <a:r>
-              <a:t>1. Scattered Context &amp; Information Silos</a:t>
-            </a:r>
-          </a:p>
-          <a:p>
-            <a:pPr>
-              <a:spcAft>
-                <a:spcPts val="1400"/>
-              </a:spcAft>
-              <a:defRPr sz="1300">
-                <a:solidFill>
-                  <a:srgbClr val="334155"/>
-                </a:solidFill>
-                <a:latin typeface="Calibri"/>
-              </a:defRPr>
-            </a:pPr>
-            <a:r>
-              <a:t>In procurement, lending, and claims, critical evidence is fragmented across Google Drive, old email threads, ERP ledgers, and employee heads. Nobody has the full picture at intake.</a:t>
-            </a:r>
-          </a:p>
-          <a:p>
-            <a:pPr>
-              <a:spcAft>
-                <a:spcPts val="300"/>
-              </a:spcAft>
-              <a:defRPr sz="1500" b="1">
-                <a:solidFill>
-                  <a:srgbClr val="1E293B"/>
-                </a:solidFill>
-                <a:latin typeface="Calibri"/>
-              </a:defRPr>
-            </a:pPr>
-            <a:r>
-              <a:t>2. Expensive Decision Ping-Pong</a:t>
-            </a:r>
-          </a:p>
-          <a:p>
-            <a:pPr>
-              <a:spcAft>
-                <a:spcPts val="1400"/>
-              </a:spcAft>
-              <a:defRPr sz="1300">
-                <a:solidFill>
-                  <a:srgbClr val="334155"/>
-                </a:solidFill>
-                <a:latin typeface="Calibri"/>
-              </a:defRPr>
-            </a:pPr>
-            <a:r>
-              <a:t>Files bounce between departments for days: 'Where is the SOC2 cert?', 'Did Finance approve?' This repetitive chasing accounts for up to 70% of total approval cycle delays.</a:t>
-            </a:r>
-          </a:p>
-          <a:p>
-            <a:pPr>
-              <a:spcAft>
-                <a:spcPts val="300"/>
-              </a:spcAft>
-              <a:defRPr sz="1500" b="1">
-                <a:solidFill>
-                  <a:srgbClr val="1E293B"/>
-                </a:solidFill>
-                <a:latin typeface="Calibri"/>
-              </a:defRPr>
-            </a:pPr>
-            <a:r>
-              <a:t>3. Generative AI Hallucination &amp; Risk</a:t>
-            </a:r>
-          </a:p>
-          <a:p>
-            <a:pPr>
-              <a:spcAft>
-                <a:spcPts val="1400"/>
-              </a:spcAft>
-              <a:defRPr sz="1300">
-                <a:solidFill>
-                  <a:srgbClr val="334155"/>
-                </a:solidFill>
-                <a:latin typeface="Calibri"/>
-              </a:defRPr>
-            </a:pPr>
-            <a:r>
-              <a:t>Standard LLMs ask 'What should I decide?' and confidently guess even when missing 50% of the facts—creating catastrophic compliance, financial, and legal liabilities in production.</a:t>
+              <a:t>THE PROBLEM: WHY ENTERPRISE DECISIONS FAIL</a:t>
             </a:r>
           </a:p>
         </p:txBody>
@@ -13276,18 +13164,18 @@
         </p:nvSpPr>
         <p:spPr>
           <a:xfrm>
-            <a:off x="9326880" y="2468880"/>
-            <a:ext cx="7936992" cy="6949440"/>
+            <a:off x="1280160" y="3108960"/>
+            <a:ext cx="7315200" cy="1554480"/>
           </a:xfrm>
           <a:prstGeom prst="roundRect">
             <a:avLst/>
           </a:prstGeom>
           <a:solidFill>
-            <a:srgbClr val="FFFFFF"/>
+            <a:srgbClr val="FEF2F2"/>
           </a:solidFill>
           <a:ln w="19050">
             <a:solidFill>
-              <a:srgbClr val="CBD5E1"/>
+              <a:srgbClr val="FCA5A5"/>
             </a:solidFill>
           </a:ln>
         </p:spPr>
@@ -13306,62 +13194,387 @@
           </a:fontRef>
         </p:style>
         <p:txBody>
-          <a:bodyPr rtlCol="0" anchor="t" lIns="365760" rIns="365760" tIns="365760" bIns="365760" wrap="square"/>
+          <a:bodyPr rtlCol="0" anchor="ctr" lIns="228600" rIns="228600" tIns="182880" wrap="square"/>
           <a:lstStyle/>
           <a:p>
             <a:pPr algn="ctr">
               <a:spcAft>
-                <a:spcPts val="600"/>
-              </a:spcAft>
-              <a:defRPr sz="2000" b="1">
-                <a:solidFill>
-                  <a:srgbClr val="0D9488"/>
+                <a:spcPts val="400"/>
+              </a:spcAft>
+            </a:pPr>
+            <a:r>
+              <a:rPr sz="1400" b="1">
+                <a:solidFill>
+                  <a:srgbClr val="DC2626"/>
+                </a:solidFill>
+                <a:latin typeface="Calibri"/>
+              </a:rPr>
+              <a:t>1. Scattered Context &amp; Silos  </a:t>
+            </a:r>
+            <a:r>
+              <a:rPr sz="1100" b="1">
+                <a:solidFill>
+                  <a:srgbClr val="1E293B"/>
+                </a:solidFill>
+                <a:latin typeface="Calibri"/>
+              </a:rPr>
+              <a:t>[Drive, Email, NetSuite ERP, Spreadsheets]</a:t>
+            </a:r>
+          </a:p>
+          <a:p>
+            <a:pPr>
+              <a:defRPr sz="1200">
+                <a:solidFill>
+                  <a:srgbClr val="334155"/>
                 </a:solidFill>
                 <a:latin typeface="Calibri"/>
               </a:defRPr>
             </a:pPr>
             <a:r>
-              <a:t>OUR SOLUTION: THE COMPLETENESS ENGINE</a:t>
+              <a:t>Information is never in one place at intake. Gaps are discovered late.</a:t>
+            </a:r>
+          </a:p>
+        </p:txBody>
+      </p:sp>
+      <p:sp>
+        <p:nvSpPr>
+          <p:cNvPr id="130" name="Rounded Rectangle 129"/>
+          <p:cNvSpPr/>
+          <p:nvPr/>
+        </p:nvSpPr>
+        <p:spPr>
+          <a:xfrm>
+            <a:off x="1280160" y="4800600"/>
+            <a:ext cx="7315200" cy="1554480"/>
+          </a:xfrm>
+          <a:prstGeom prst="roundRect">
+            <a:avLst/>
+          </a:prstGeom>
+          <a:solidFill>
+            <a:srgbClr val="FEF3C7"/>
+          </a:solidFill>
+          <a:ln w="19050">
+            <a:solidFill>
+              <a:srgbClr val="FCD34D"/>
+            </a:solidFill>
+          </a:ln>
+        </p:spPr>
+        <p:style>
+          <a:lnRef idx="1">
+            <a:schemeClr val="accent1"/>
+          </a:lnRef>
+          <a:fillRef idx="3">
+            <a:schemeClr val="accent1"/>
+          </a:fillRef>
+          <a:effectRef idx="2">
+            <a:schemeClr val="accent1"/>
+          </a:effectRef>
+          <a:fontRef idx="minor">
+            <a:schemeClr val="lt1"/>
+          </a:fontRef>
+        </p:style>
+        <p:txBody>
+          <a:bodyPr rtlCol="0" anchor="ctr" lIns="228600" rIns="228600" tIns="182880" wrap="square"/>
+          <a:lstStyle/>
+          <a:p>
+            <a:pPr algn="ctr">
+              <a:spcAft>
+                <a:spcPts val="400"/>
+              </a:spcAft>
+            </a:pPr>
+            <a:r>
+              <a:rPr sz="1400" b="1">
+                <a:solidFill>
+                  <a:srgbClr val="D97706"/>
+                </a:solidFill>
+                <a:latin typeface="Calibri"/>
+              </a:rPr>
+              <a:t>2. Endless Approval Ping-Pong  </a:t>
+            </a:r>
+            <a:r>
+              <a:rPr sz="1100" b="1">
+                <a:solidFill>
+                  <a:srgbClr val="1E293B"/>
+                </a:solidFill>
+                <a:latin typeface="Calibri"/>
+              </a:rPr>
+              <a:t>[2.5 Days Wasted Per Approval]</a:t>
             </a:r>
           </a:p>
           <a:p>
             <a:pPr>
-              <a:spcAft>
-                <a:spcPts val="1600"/>
-              </a:spcAft>
-              <a:defRPr sz="1300" i="1">
-                <a:solidFill>
-                  <a:srgbClr val="64748B"/>
+              <a:defRPr sz="1200">
+                <a:solidFill>
+                  <a:srgbClr val="334155"/>
                 </a:solidFill>
                 <a:latin typeface="Calibri"/>
               </a:defRPr>
             </a:pPr>
             <a:r>
-              <a:t>The core paradigm shift: verify sufficiency before deciding, then self-heal:</a:t>
+              <a:t>'You forgot the SOC2 cert', 'Where is budget approval?' Bouncing files wastes 70% of time.</a:t>
+            </a:r>
+          </a:p>
+        </p:txBody>
+      </p:sp>
+      <p:sp>
+        <p:nvSpPr>
+          <p:cNvPr id="131" name="Rounded Rectangle 130"/>
+          <p:cNvSpPr/>
+          <p:nvPr/>
+        </p:nvSpPr>
+        <p:spPr>
+          <a:xfrm>
+            <a:off x="1280160" y="6492240"/>
+            <a:ext cx="7315200" cy="1554480"/>
+          </a:xfrm>
+          <a:prstGeom prst="roundRect">
+            <a:avLst/>
+          </a:prstGeom>
+          <a:solidFill>
+            <a:srgbClr val="FEF2F2"/>
+          </a:solidFill>
+          <a:ln w="19050">
+            <a:solidFill>
+              <a:srgbClr val="FCA5A5"/>
+            </a:solidFill>
+          </a:ln>
+        </p:spPr>
+        <p:style>
+          <a:lnRef idx="1">
+            <a:schemeClr val="accent1"/>
+          </a:lnRef>
+          <a:fillRef idx="3">
+            <a:schemeClr val="accent1"/>
+          </a:fillRef>
+          <a:effectRef idx="2">
+            <a:schemeClr val="accent1"/>
+          </a:effectRef>
+          <a:fontRef idx="minor">
+            <a:schemeClr val="lt1"/>
+          </a:fontRef>
+        </p:style>
+        <p:txBody>
+          <a:bodyPr rtlCol="0" anchor="ctr" lIns="228600" rIns="228600" tIns="182880" wrap="square"/>
+          <a:lstStyle/>
+          <a:p>
+            <a:pPr algn="ctr">
+              <a:spcAft>
+                <a:spcPts val="400"/>
+              </a:spcAft>
+            </a:pPr>
+            <a:r>
+              <a:rPr sz="1400" b="1">
+                <a:solidFill>
+                  <a:srgbClr val="DC2626"/>
+                </a:solidFill>
+                <a:latin typeface="Calibri"/>
+              </a:rPr>
+              <a:t>3. Dangerous GenAI Hallucination  </a:t>
+            </a:r>
+            <a:r>
+              <a:rPr sz="1100" b="1">
+                <a:solidFill>
+                  <a:srgbClr val="1E293B"/>
+                </a:solidFill>
+                <a:latin typeface="Calibri"/>
+              </a:rPr>
+              <a:t>[Standard LLMs Confidently Guess]</a:t>
             </a:r>
           </a:p>
           <a:p>
             <a:pPr>
-              <a:spcAft>
-                <a:spcPts val="200"/>
-              </a:spcAft>
-              <a:defRPr sz="1400" b="1">
-                <a:solidFill>
-                  <a:srgbClr val="1E293B"/>
+              <a:defRPr sz="1200">
+                <a:solidFill>
+                  <a:srgbClr val="334155"/>
                 </a:solidFill>
                 <a:latin typeface="Calibri"/>
               </a:defRPr>
             </a:pPr>
             <a:r>
-              <a:t>1. Core Paradigm Inversion</a:t>
+              <a:t>Most AI asks 'What should I decide?' and hallucinates when missing 50% of the facts.</a:t>
+            </a:r>
+          </a:p>
+        </p:txBody>
+      </p:sp>
+      <p:sp>
+        <p:nvSpPr>
+          <p:cNvPr id="132" name="Rounded Rectangle 131"/>
+          <p:cNvSpPr/>
+          <p:nvPr/>
+        </p:nvSpPr>
+        <p:spPr>
+          <a:xfrm>
+            <a:off x="1280160" y="8229600"/>
+            <a:ext cx="7315200" cy="868680"/>
+          </a:xfrm>
+          <a:prstGeom prst="roundRect">
+            <a:avLst/>
+          </a:prstGeom>
+          <a:solidFill>
+            <a:srgbClr val="0F172A"/>
+          </a:solidFill>
+          <a:ln>
+            <a:noFill/>
+          </a:ln>
+        </p:spPr>
+        <p:style>
+          <a:lnRef idx="1">
+            <a:schemeClr val="accent1"/>
+          </a:lnRef>
+          <a:fillRef idx="3">
+            <a:schemeClr val="accent1"/>
+          </a:fillRef>
+          <a:effectRef idx="2">
+            <a:schemeClr val="accent1"/>
+          </a:effectRef>
+          <a:fontRef idx="minor">
+            <a:schemeClr val="lt1"/>
+          </a:fontRef>
+        </p:style>
+        <p:txBody>
+          <a:bodyPr rtlCol="0" anchor="ctr" lIns="274320" rIns="274320"/>
+          <a:lstStyle/>
+          <a:p>
+            <a:pPr algn="ctr">
+              <a:defRPr sz="1250" b="1">
+                <a:solidFill>
+                  <a:srgbClr val="FFFFFF"/>
+                </a:solidFill>
+                <a:latin typeface="Calibri"/>
+              </a:defRPr>
+            </a:pPr>
+            <a:r>
+              <a:t>Result: Decisions are either paralyzed for days or made blindly with missing facts.</a:t>
+            </a:r>
+          </a:p>
+        </p:txBody>
+      </p:sp>
+      <p:sp>
+        <p:nvSpPr>
+          <p:cNvPr id="133" name="Rounded Rectangle 132"/>
+          <p:cNvSpPr/>
+          <p:nvPr/>
+        </p:nvSpPr>
+        <p:spPr>
+          <a:xfrm>
+            <a:off x="9326880" y="2468880"/>
+            <a:ext cx="7936992" cy="6949440"/>
+          </a:xfrm>
+          <a:prstGeom prst="roundRect">
+            <a:avLst/>
+          </a:prstGeom>
+          <a:solidFill>
+            <a:srgbClr val="FFFFFF"/>
+          </a:solidFill>
+          <a:ln w="19050">
+            <a:solidFill>
+              <a:srgbClr val="5EEAD4"/>
+            </a:solidFill>
+          </a:ln>
+        </p:spPr>
+        <p:style>
+          <a:lnRef idx="1">
+            <a:schemeClr val="accent1"/>
+          </a:lnRef>
+          <a:fillRef idx="3">
+            <a:schemeClr val="accent1"/>
+          </a:fillRef>
+          <a:effectRef idx="2">
+            <a:schemeClr val="accent1"/>
+          </a:effectRef>
+          <a:fontRef idx="minor">
+            <a:schemeClr val="lt1"/>
+          </a:fontRef>
+        </p:style>
+        <p:txBody>
+          <a:bodyPr rtlCol="0" anchor="ctr" lIns="365760" rIns="365760" tIns="320040"/>
+          <a:lstStyle/>
+          <a:p>
+            <a:pPr algn="ctr">
+              <a:spcAft>
+                <a:spcPts val="1400"/>
+              </a:spcAft>
+              <a:defRPr sz="1800" b="1">
+                <a:solidFill>
+                  <a:srgbClr val="0D9488"/>
+                </a:solidFill>
+                <a:latin typeface="Calibri"/>
+              </a:defRPr>
+            </a:pPr>
+            <a:r>
+              <a:t>THE SOLUTION: DECISION COMPLETENESS ENGINE</a:t>
+            </a:r>
+          </a:p>
+        </p:txBody>
+      </p:sp>
+      <p:sp>
+        <p:nvSpPr>
+          <p:cNvPr id="134" name="Rounded Rectangle 133"/>
+          <p:cNvSpPr/>
+          <p:nvPr/>
+        </p:nvSpPr>
+        <p:spPr>
+          <a:xfrm>
+            <a:off x="9601200" y="3108960"/>
+            <a:ext cx="7388352" cy="1051560"/>
+          </a:xfrm>
+          <a:prstGeom prst="roundRect">
+            <a:avLst/>
+          </a:prstGeom>
+          <a:solidFill>
+            <a:srgbClr val="F0FDFA"/>
+          </a:solidFill>
+          <a:ln w="19050">
+            <a:solidFill>
+              <a:srgbClr val="5EEAD4"/>
+            </a:solidFill>
+          </a:ln>
+        </p:spPr>
+        <p:style>
+          <a:lnRef idx="1">
+            <a:schemeClr val="accent1"/>
+          </a:lnRef>
+          <a:fillRef idx="3">
+            <a:schemeClr val="accent1"/>
+          </a:fillRef>
+          <a:effectRef idx="2">
+            <a:schemeClr val="accent1"/>
+          </a:effectRef>
+          <a:fontRef idx="minor">
+            <a:schemeClr val="lt1"/>
+          </a:fontRef>
+        </p:style>
+        <p:txBody>
+          <a:bodyPr rtlCol="0" anchor="ctr" lIns="228600" rIns="228600" tIns="109728" wrap="square"/>
+          <a:lstStyle/>
+          <a:p>
+            <a:pPr algn="ctr">
+              <a:spcAft>
+                <a:spcPts val="200"/>
+              </a:spcAft>
+            </a:pPr>
+            <a:r>
+              <a:rPr sz="1300" b="1">
+                <a:solidFill>
+                  <a:srgbClr val="0D9488"/>
+                </a:solidFill>
+                <a:latin typeface="Calibri"/>
+              </a:rPr>
+              <a:t>1. Core Inversion  </a:t>
+            </a:r>
+            <a:r>
+              <a:rPr sz="1100" b="1">
+                <a:solidFill>
+                  <a:srgbClr val="1E293B"/>
+                </a:solidFill>
+                <a:latin typeface="Calibri"/>
+              </a:rPr>
+              <a:t>[Do I have enough evidence to decide?]</a:t>
             </a:r>
           </a:p>
           <a:p>
             <a:pPr>
-              <a:spcAft>
-                <a:spcPts val="800"/>
-              </a:spcAft>
-              <a:defRPr sz="1250">
+              <a:defRPr sz="1150">
                 <a:solidFill>
                   <a:srgbClr val="334155"/>
                 </a:solidFill>
@@ -13369,31 +13582,159 @@
               </a:defRPr>
             </a:pPr>
             <a:r>
-              <a:t>Instead of asking 'What should I decide?', our AI asks first: 'Do I have enough verified evidence to decide at all?'—mimicking a senior judge or lead physician.</a:t>
+              <a:t>Like a lead doctor ordering tests before diagnosing, we verify completeness first.</a:t>
+            </a:r>
+          </a:p>
+        </p:txBody>
+      </p:sp>
+      <p:sp>
+        <p:nvSpPr>
+          <p:cNvPr id="135" name="Rounded Rectangle 134"/>
+          <p:cNvSpPr/>
+          <p:nvPr/>
+        </p:nvSpPr>
+        <p:spPr>
+          <a:xfrm>
+            <a:off x="9601200" y="4233672"/>
+            <a:ext cx="7388352" cy="1051560"/>
+          </a:xfrm>
+          <a:prstGeom prst="roundRect">
+            <a:avLst/>
+          </a:prstGeom>
+          <a:solidFill>
+            <a:srgbClr val="EEF2FF"/>
+          </a:solidFill>
+          <a:ln w="19050">
+            <a:solidFill>
+              <a:srgbClr val="C7D2FE"/>
+            </a:solidFill>
+          </a:ln>
+        </p:spPr>
+        <p:style>
+          <a:lnRef idx="1">
+            <a:schemeClr val="accent1"/>
+          </a:lnRef>
+          <a:fillRef idx="3">
+            <a:schemeClr val="accent1"/>
+          </a:fillRef>
+          <a:effectRef idx="2">
+            <a:schemeClr val="accent1"/>
+          </a:effectRef>
+          <a:fontRef idx="minor">
+            <a:schemeClr val="lt1"/>
+          </a:fontRef>
+        </p:style>
+        <p:txBody>
+          <a:bodyPr rtlCol="0" anchor="ctr" lIns="228600" rIns="228600" tIns="109728" wrap="square"/>
+          <a:lstStyle/>
+          <a:p>
+            <a:pPr algn="ctr">
+              <a:spcAft>
+                <a:spcPts val="200"/>
+              </a:spcAft>
+            </a:pPr>
+            <a:r>
+              <a:rPr sz="1300" b="1">
+                <a:solidFill>
+                  <a:srgbClr val="4F46E5"/>
+                </a:solidFill>
+                <a:latin typeface="Calibri"/>
+              </a:rPr>
+              <a:t>2. Dynamic Planning  </a:t>
+            </a:r>
+            <a:r>
+              <a:rPr sz="1100" b="1">
+                <a:solidFill>
+                  <a:srgbClr val="1E293B"/>
+                </a:solidFill>
+                <a:latin typeface="Calibri"/>
+              </a:rPr>
+              <a:t>[Inferred Evidence Specs (Not Checklists)]</a:t>
             </a:r>
           </a:p>
           <a:p>
             <a:pPr>
-              <a:spcAft>
-                <a:spcPts val="200"/>
-              </a:spcAft>
-              <a:defRPr sz="1400" b="1">
-                <a:solidFill>
-                  <a:srgbClr val="1E293B"/>
+              <a:defRPr sz="1150">
+                <a:solidFill>
+                  <a:srgbClr val="334155"/>
                 </a:solidFill>
                 <a:latin typeface="Calibri"/>
               </a:defRPr>
             </a:pPr>
             <a:r>
-              <a:t>2. Dynamic Evidence Planning (Not Hardcoded)</a:t>
+              <a:t>AI dynamically deduces what evidence is needed based on transaction amount, domain, and risk tier.</a:t>
+            </a:r>
+          </a:p>
+        </p:txBody>
+      </p:sp>
+      <p:sp>
+        <p:nvSpPr>
+          <p:cNvPr id="136" name="Rounded Rectangle 135"/>
+          <p:cNvSpPr/>
+          <p:nvPr/>
+        </p:nvSpPr>
+        <p:spPr>
+          <a:xfrm>
+            <a:off x="9601200" y="5358384"/>
+            <a:ext cx="7388352" cy="1051560"/>
+          </a:xfrm>
+          <a:prstGeom prst="roundRect">
+            <a:avLst/>
+          </a:prstGeom>
+          <a:solidFill>
+            <a:srgbClr val="FEF2F2"/>
+          </a:solidFill>
+          <a:ln w="19050">
+            <a:solidFill>
+              <a:srgbClr val="FCA5A5"/>
+            </a:solidFill>
+          </a:ln>
+        </p:spPr>
+        <p:style>
+          <a:lnRef idx="1">
+            <a:schemeClr val="accent1"/>
+          </a:lnRef>
+          <a:fillRef idx="3">
+            <a:schemeClr val="accent1"/>
+          </a:fillRef>
+          <a:effectRef idx="2">
+            <a:schemeClr val="accent1"/>
+          </a:effectRef>
+          <a:fontRef idx="minor">
+            <a:schemeClr val="lt1"/>
+          </a:fontRef>
+        </p:style>
+        <p:txBody>
+          <a:bodyPr rtlCol="0" anchor="ctr" lIns="228600" rIns="228600" tIns="109728" wrap="square"/>
+          <a:lstStyle/>
+          <a:p>
+            <a:pPr algn="ctr">
+              <a:spcAft>
+                <a:spcPts val="200"/>
+              </a:spcAft>
+            </a:pPr>
+            <a:r>
+              <a:rPr sz="1300" b="1">
+                <a:solidFill>
+                  <a:srgbClr val="DC2626"/>
+                </a:solidFill>
+                <a:latin typeface="Calibri"/>
+              </a:rPr>
+              <a:t>3. Zero-Hallucination Gate  </a:t>
+            </a:r>
+            <a:r>
+              <a:rPr sz="1100" b="1">
+                <a:solidFill>
+                  <a:srgbClr val="1E293B"/>
+                </a:solidFill>
+                <a:latin typeface="Calibri"/>
+              </a:rPr>
+              <a:t>[Halts &amp; Calculates 0-100% Score]</a:t>
             </a:r>
           </a:p>
           <a:p>
             <a:pPr>
-              <a:spcAft>
-                <a:spcPts val="800"/>
-              </a:spcAft>
-              <a:defRPr sz="1250">
+              <a:defRPr sz="1150">
                 <a:solidFill>
                   <a:srgbClr val="334155"/>
                 </a:solidFill>
@@ -13401,31 +13742,159 @@
               </a:defRPr>
             </a:pPr>
             <a:r>
-              <a:t>The AI dynamically reasons about what evidence is required based on request type, transaction value, and risk profile—adapting across 8 enterprise domains.</a:t>
+              <a:t>Guaranteed zero speculation: if critical evidence is absent, the engine blocks decision execution.</a:t>
+            </a:r>
+          </a:p>
+        </p:txBody>
+      </p:sp>
+      <p:sp>
+        <p:nvSpPr>
+          <p:cNvPr id="137" name="Rounded Rectangle 136"/>
+          <p:cNvSpPr/>
+          <p:nvPr/>
+        </p:nvSpPr>
+        <p:spPr>
+          <a:xfrm>
+            <a:off x="9601200" y="6483096"/>
+            <a:ext cx="7388352" cy="1051560"/>
+          </a:xfrm>
+          <a:prstGeom prst="roundRect">
+            <a:avLst/>
+          </a:prstGeom>
+          <a:solidFill>
+            <a:srgbClr val="F0FDF4"/>
+          </a:solidFill>
+          <a:ln w="19050">
+            <a:solidFill>
+              <a:srgbClr val="86EFAC"/>
+            </a:solidFill>
+          </a:ln>
+        </p:spPr>
+        <p:style>
+          <a:lnRef idx="1">
+            <a:schemeClr val="accent1"/>
+          </a:lnRef>
+          <a:fillRef idx="3">
+            <a:schemeClr val="accent1"/>
+          </a:fillRef>
+          <a:effectRef idx="2">
+            <a:schemeClr val="accent1"/>
+          </a:effectRef>
+          <a:fontRef idx="minor">
+            <a:schemeClr val="lt1"/>
+          </a:fontRef>
+        </p:style>
+        <p:txBody>
+          <a:bodyPr rtlCol="0" anchor="ctr" lIns="228600" rIns="228600" tIns="109728" wrap="square"/>
+          <a:lstStyle/>
+          <a:p>
+            <a:pPr algn="ctr">
+              <a:spcAft>
+                <a:spcPts val="200"/>
+              </a:spcAft>
+            </a:pPr>
+            <a:r>
+              <a:rPr sz="1300" b="1">
+                <a:solidFill>
+                  <a:srgbClr val="16A34A"/>
+                </a:solidFill>
+                <a:latin typeface="Calibri"/>
+              </a:rPr>
+              <a:t>4. Autonomous Self-Healing  </a:t>
+            </a:r>
+            <a:r>
+              <a:rPr sz="1100" b="1">
+                <a:solidFill>
+                  <a:srgbClr val="1E293B"/>
+                </a:solidFill>
+                <a:latin typeface="Calibri"/>
+              </a:rPr>
+              <a:t>[Searches Drive, Mail, ERP, Web]</a:t>
             </a:r>
           </a:p>
           <a:p>
             <a:pPr>
-              <a:spcAft>
-                <a:spcPts val="200"/>
-              </a:spcAft>
-              <a:defRPr sz="1400" b="1">
-                <a:solidFill>
-                  <a:srgbClr val="1E293B"/>
+              <a:defRPr sz="1150">
+                <a:solidFill>
+                  <a:srgbClr val="334155"/>
                 </a:solidFill>
                 <a:latin typeface="Calibri"/>
               </a:defRPr>
             </a:pPr>
             <a:r>
-              <a:t>3. Zero-Hallucination Gatekeeper</a:t>
+              <a:t>Silently recovers missing proof from connected enterprise silos before bothering humans.</a:t>
+            </a:r>
+          </a:p>
+        </p:txBody>
+      </p:sp>
+      <p:sp>
+        <p:nvSpPr>
+          <p:cNvPr id="138" name="Rounded Rectangle 137"/>
+          <p:cNvSpPr/>
+          <p:nvPr/>
+        </p:nvSpPr>
+        <p:spPr>
+          <a:xfrm>
+            <a:off x="9601200" y="7607808"/>
+            <a:ext cx="7388352" cy="1051560"/>
+          </a:xfrm>
+          <a:prstGeom prst="roundRect">
+            <a:avLst/>
+          </a:prstGeom>
+          <a:solidFill>
+            <a:srgbClr val="FEF3C7"/>
+          </a:solidFill>
+          <a:ln w="19050">
+            <a:solidFill>
+              <a:srgbClr val="FCD34D"/>
+            </a:solidFill>
+          </a:ln>
+        </p:spPr>
+        <p:style>
+          <a:lnRef idx="1">
+            <a:schemeClr val="accent1"/>
+          </a:lnRef>
+          <a:fillRef idx="3">
+            <a:schemeClr val="accent1"/>
+          </a:fillRef>
+          <a:effectRef idx="2">
+            <a:schemeClr val="accent1"/>
+          </a:effectRef>
+          <a:fontRef idx="minor">
+            <a:schemeClr val="lt1"/>
+          </a:fontRef>
+        </p:style>
+        <p:txBody>
+          <a:bodyPr rtlCol="0" anchor="ctr" lIns="228600" rIns="228600" tIns="109728" wrap="square"/>
+          <a:lstStyle/>
+          <a:p>
+            <a:pPr algn="ctr">
+              <a:spcAft>
+                <a:spcPts val="200"/>
+              </a:spcAft>
+            </a:pPr>
+            <a:r>
+              <a:rPr sz="1300" b="1">
+                <a:solidFill>
+                  <a:srgbClr val="D97706"/>
+                </a:solidFill>
+                <a:latin typeface="Calibri"/>
+              </a:rPr>
+              <a:t>5. Precision Human-in-the-Loop  </a:t>
+            </a:r>
+            <a:r>
+              <a:rPr sz="1100" b="1">
+                <a:solidFill>
+                  <a:srgbClr val="1E293B"/>
+                </a:solidFill>
+                <a:latin typeface="Calibri"/>
+              </a:rPr>
+              <a:t>[15-Sec Targeted Micro-Ask]</a:t>
             </a:r>
           </a:p>
           <a:p>
             <a:pPr>
-              <a:spcAft>
-                <a:spcPts val="800"/>
-              </a:spcAft>
-              <a:defRPr sz="1250">
+              <a:defRPr sz="1150">
                 <a:solidFill>
                   <a:srgbClr val="334155"/>
                 </a:solidFill>
@@ -13433,71 +13902,7 @@
               </a:defRPr>
             </a:pPr>
             <a:r>
-              <a:t>Blocks execution when critical items are absent. It refuses to guess and calculates an objective completeness score (0-100%).</a:t>
-            </a:r>
-          </a:p>
-          <a:p>
-            <a:pPr>
-              <a:spcAft>
-                <a:spcPts val="200"/>
-              </a:spcAft>
-              <a:defRPr sz="1400" b="1">
-                <a:solidFill>
-                  <a:srgbClr val="1E293B"/>
-                </a:solidFill>
-                <a:latin typeface="Calibri"/>
-              </a:defRPr>
-            </a:pPr>
-            <a:r>
-              <a:t>4. Autonomous Multi-Source Self-Healing</a:t>
-            </a:r>
-          </a:p>
-          <a:p>
-            <a:pPr>
-              <a:spcAft>
-                <a:spcPts val="800"/>
-              </a:spcAft>
-              <a:defRPr sz="1250">
-                <a:solidFill>
-                  <a:srgbClr val="334155"/>
-                </a:solidFill>
-                <a:latin typeface="Calibri"/>
-              </a:defRPr>
-            </a:pPr>
-            <a:r>
-              <a:t>Silently searches Google Drive vaults, Gmail/M365 archives, NetSuite ERP, and regulatory databases to recover missing documents automatically.</a:t>
-            </a:r>
-          </a:p>
-          <a:p>
-            <a:pPr>
-              <a:spcAft>
-                <a:spcPts val="200"/>
-              </a:spcAft>
-              <a:defRPr sz="1400" b="1">
-                <a:solidFill>
-                  <a:srgbClr val="1E293B"/>
-                </a:solidFill>
-                <a:latin typeface="Calibri"/>
-              </a:defRPr>
-            </a:pPr>
-            <a:r>
-              <a:t>5. Precision Human-in-the-Loop (HITL)</a:t>
-            </a:r>
-          </a:p>
-          <a:p>
-            <a:pPr>
-              <a:spcAft>
-                <a:spcPts val="800"/>
-              </a:spcAft>
-              <a:defRPr sz="1250">
-                <a:solidFill>
-                  <a:srgbClr val="334155"/>
-                </a:solidFill>
-                <a:latin typeface="Calibri"/>
-              </a:defRPr>
-            </a:pPr>
-            <a:r>
-              <a:t>Sends a surgical micro-request for ONLY the single missing piece (e.g. 1-click VP budget approval in 15 seconds, not 30 minutes).</a:t>
+              <a:t>Sends a surgical Slack/Email card for ONLY the remaining missing delta (e.g. 1-click VP budget approval).</a:t>
             </a:r>
           </a:p>
         </p:txBody>
@@ -13683,13 +14088,295 @@
         <p:spPr>
           <a:xfrm>
             <a:off x="1024128" y="2468880"/>
-            <a:ext cx="16239744" cy="1536192"/>
+            <a:ext cx="16239744" cy="1572768"/>
           </a:xfrm>
           <a:prstGeom prst="roundRect">
             <a:avLst/>
           </a:prstGeom>
           <a:solidFill>
-            <a:srgbClr val="FFFFFF"/>
+            <a:srgbClr val="EEF2FF"/>
+          </a:solidFill>
+          <a:ln w="19050">
+            <a:solidFill>
+              <a:srgbClr val="C7D2FE"/>
+            </a:solidFill>
+          </a:ln>
+        </p:spPr>
+        <p:style>
+          <a:lnRef idx="1">
+            <a:schemeClr val="accent1"/>
+          </a:lnRef>
+          <a:fillRef idx="3">
+            <a:schemeClr val="accent1"/>
+          </a:fillRef>
+          <a:effectRef idx="2">
+            <a:schemeClr val="accent1"/>
+          </a:effectRef>
+          <a:fontRef idx="minor">
+            <a:schemeClr val="lt1"/>
+          </a:fontRef>
+        </p:style>
+        <p:txBody>
+          <a:bodyPr rtlCol="0" anchor="t" lIns="365760" rIns="365760" tIns="182880" wrap="square"/>
+          <a:lstStyle/>
+          <a:p>
+            <a:pPr algn="ctr">
+              <a:spcAft>
+                <a:spcPts val="300"/>
+              </a:spcAft>
+              <a:defRPr sz="1600" b="1">
+                <a:solidFill>
+                  <a:srgbClr val="4F46E5"/>
+                </a:solidFill>
+                <a:latin typeface="Calibri"/>
+              </a:defRPr>
+            </a:pPr>
+            <a:r>
+              <a:t>LAYER 1: AGENTIC CORE &amp; REASONING ENGINE</a:t>
+            </a:r>
+          </a:p>
+          <a:p>
+            <a:pPr>
+              <a:spcAft>
+                <a:spcPts val="400"/>
+              </a:spcAft>
+              <a:defRPr sz="1300">
+                <a:solidFill>
+                  <a:srgbClr val="334155"/>
+                </a:solidFill>
+                <a:latin typeface="Calibri"/>
+              </a:defRPr>
+            </a:pPr>
+            <a:r>
+              <a:t>Dynamic Evidence Specification Planner • Gap Auditor &amp; Completeness Scorer (0-100%) • Zero-Hallucination Gatekeeper • Deliberator &amp; Confidence Calibration</a:t>
+            </a:r>
+          </a:p>
+          <a:p>
+            <a:r>
+              <a:rPr sz="1200" b="1">
+                <a:solidFill>
+                  <a:srgbClr val="1E293B"/>
+                </a:solidFill>
+                <a:latin typeface="Calibri"/>
+              </a:rPr>
+              <a:t>Tech Stack: </a:t>
+            </a:r>
+            <a:r>
+              <a:rPr sz="1200">
+                <a:solidFill>
+                  <a:srgbClr val="4F46E5"/>
+                </a:solidFill>
+                <a:latin typeface="Calibri"/>
+              </a:rPr>
+              <a:t>Python 3.13 • Pydantic v2 Type-Safe Contracts • Groq Llama 3.3 70B / Gemini 1.5 Pro</a:t>
+            </a:r>
+          </a:p>
+        </p:txBody>
+      </p:sp>
+      <p:sp>
+        <p:nvSpPr>
+          <p:cNvPr id="136" name="Rounded Rectangle 135"/>
+          <p:cNvSpPr/>
+          <p:nvPr/>
+        </p:nvSpPr>
+        <p:spPr>
+          <a:xfrm>
+            <a:off x="1024128" y="4206240"/>
+            <a:ext cx="16239744" cy="1572768"/>
+          </a:xfrm>
+          <a:prstGeom prst="roundRect">
+            <a:avLst/>
+          </a:prstGeom>
+          <a:solidFill>
+            <a:srgbClr val="F0FDFA"/>
+          </a:solidFill>
+          <a:ln w="19050">
+            <a:solidFill>
+              <a:srgbClr val="5EEAD4"/>
+            </a:solidFill>
+          </a:ln>
+        </p:spPr>
+        <p:style>
+          <a:lnRef idx="1">
+            <a:schemeClr val="accent1"/>
+          </a:lnRef>
+          <a:fillRef idx="3">
+            <a:schemeClr val="accent1"/>
+          </a:fillRef>
+          <a:effectRef idx="2">
+            <a:schemeClr val="accent1"/>
+          </a:effectRef>
+          <a:fontRef idx="minor">
+            <a:schemeClr val="lt1"/>
+          </a:fontRef>
+        </p:style>
+        <p:txBody>
+          <a:bodyPr rtlCol="0" anchor="t" lIns="365760" rIns="365760" tIns="182880" wrap="square"/>
+          <a:lstStyle/>
+          <a:p>
+            <a:pPr algn="ctr">
+              <a:spcAft>
+                <a:spcPts val="300"/>
+              </a:spcAft>
+              <a:defRPr sz="1600" b="1">
+                <a:solidFill>
+                  <a:srgbClr val="0D9488"/>
+                </a:solidFill>
+                <a:latin typeface="Calibri"/>
+              </a:defRPr>
+            </a:pPr>
+            <a:r>
+              <a:t>LAYER 2: AUTONOMOUS MULTI-SOURCE ENTERPRISE CONNECTORS</a:t>
+            </a:r>
+          </a:p>
+          <a:p>
+            <a:pPr>
+              <a:spcAft>
+                <a:spcPts val="400"/>
+              </a:spcAft>
+              <a:defRPr sz="1300">
+                <a:solidFill>
+                  <a:srgbClr val="334155"/>
+                </a:solidFill>
+                <a:latin typeface="Calibri"/>
+              </a:defRPr>
+            </a:pPr>
+            <a:r>
+              <a:t>Corporate Google Drive Vault (Indexed PDFs, SOC2, Appraisals) • Mailbox Archive (Gmail / M365 Exchange Threads) • ERP Financial Ledger (NetSuite / SAP GL Balances) • Regulatory Registries (D&amp;B, OFAC, SOS)</a:t>
+            </a:r>
+          </a:p>
+          <a:p>
+            <a:r>
+              <a:rPr sz="1200" b="1">
+                <a:solidFill>
+                  <a:srgbClr val="1E293B"/>
+                </a:solidFill>
+                <a:latin typeface="Calibri"/>
+              </a:rPr>
+              <a:t>Tech Stack: </a:t>
+            </a:r>
+            <a:r>
+              <a:rPr sz="1200">
+                <a:solidFill>
+                  <a:srgbClr val="0D9488"/>
+                </a:solidFill>
+                <a:latin typeface="Calibri"/>
+              </a:rPr>
+              <a:t>Vector Embeddings • Fuzzy Matcher • REST APIs • Pluggable BaseConnector Abstraction</a:t>
+            </a:r>
+          </a:p>
+        </p:txBody>
+      </p:sp>
+      <p:sp>
+        <p:nvSpPr>
+          <p:cNvPr id="137" name="Rounded Rectangle 136"/>
+          <p:cNvSpPr/>
+          <p:nvPr/>
+        </p:nvSpPr>
+        <p:spPr>
+          <a:xfrm>
+            <a:off x="1024128" y="5943600"/>
+            <a:ext cx="16239744" cy="1572768"/>
+          </a:xfrm>
+          <a:prstGeom prst="roundRect">
+            <a:avLst/>
+          </a:prstGeom>
+          <a:solidFill>
+            <a:srgbClr val="FEF3C7"/>
+          </a:solidFill>
+          <a:ln w="19050">
+            <a:solidFill>
+              <a:srgbClr val="FCD34D"/>
+            </a:solidFill>
+          </a:ln>
+        </p:spPr>
+        <p:style>
+          <a:lnRef idx="1">
+            <a:schemeClr val="accent1"/>
+          </a:lnRef>
+          <a:fillRef idx="3">
+            <a:schemeClr val="accent1"/>
+          </a:fillRef>
+          <a:effectRef idx="2">
+            <a:schemeClr val="accent1"/>
+          </a:effectRef>
+          <a:fontRef idx="minor">
+            <a:schemeClr val="lt1"/>
+          </a:fontRef>
+        </p:style>
+        <p:txBody>
+          <a:bodyPr rtlCol="0" anchor="t" lIns="365760" rIns="365760" tIns="182880" wrap="square"/>
+          <a:lstStyle/>
+          <a:p>
+            <a:pPr algn="ctr">
+              <a:spcAft>
+                <a:spcPts val="300"/>
+              </a:spcAft>
+              <a:defRPr sz="1600" b="1">
+                <a:solidFill>
+                  <a:srgbClr val="D97706"/>
+                </a:solidFill>
+                <a:latin typeface="Calibri"/>
+              </a:defRPr>
+            </a:pPr>
+            <a:r>
+              <a:t>LAYER 3: PRECISION HUMAN-IN-THE-LOOP &amp; ACTION DISPATCHERS</a:t>
+            </a:r>
+          </a:p>
+          <a:p>
+            <a:pPr>
+              <a:spcAft>
+                <a:spcPts val="400"/>
+              </a:spcAft>
+              <a:defRPr sz="1300">
+                <a:solidFill>
+                  <a:srgbClr val="334155"/>
+                </a:solidFill>
+                <a:latin typeface="Calibri"/>
+              </a:defRPr>
+            </a:pPr>
+            <a:r>
+              <a:t>Precision Micro-Ask Engine (Role-Targeted Asks) • Interactive Slack &amp; Email Cards with 1-Click Approval • Downstream Action Execution (PO Generation, Claim Remittance EDI-835, Term Sheet)</a:t>
+            </a:r>
+          </a:p>
+          <a:p>
+            <a:r>
+              <a:rPr sz="1200" b="1">
+                <a:solidFill>
+                  <a:srgbClr val="1E293B"/>
+                </a:solidFill>
+                <a:latin typeface="Calibri"/>
+              </a:rPr>
+              <a:t>Tech Stack: </a:t>
+            </a:r>
+            <a:r>
+              <a:rPr sz="1200">
+                <a:solidFill>
+                  <a:srgbClr val="D97706"/>
+                </a:solidFill>
+                <a:latin typeface="Calibri"/>
+              </a:rPr>
+              <a:t>Slack Webhooks • Action Dispatcher Subsystem • SHA-256 Chain-of-Custody Audit Ledger</a:t>
+            </a:r>
+          </a:p>
+        </p:txBody>
+      </p:sp>
+      <p:sp>
+        <p:nvSpPr>
+          <p:cNvPr id="138" name="Rounded Rectangle 137"/>
+          <p:cNvSpPr/>
+          <p:nvPr/>
+        </p:nvSpPr>
+        <p:spPr>
+          <a:xfrm>
+            <a:off x="1024128" y="7680960"/>
+            <a:ext cx="16239744" cy="1572768"/>
+          </a:xfrm>
+          <a:prstGeom prst="roundRect">
+            <a:avLst/>
+          </a:prstGeom>
+          <a:solidFill>
+            <a:srgbClr val="F8FAFC"/>
           </a:solidFill>
           <a:ln w="19050">
             <a:solidFill>
@@ -13712,27 +14399,30 @@
           </a:fontRef>
         </p:style>
         <p:txBody>
-          <a:bodyPr rtlCol="0" anchor="ctr" lIns="365760" rIns="365760" wrap="square"/>
+          <a:bodyPr rtlCol="0" anchor="t" lIns="365760" rIns="365760" tIns="182880" wrap="square"/>
           <a:lstStyle/>
           <a:p>
             <a:pPr algn="ctr">
               <a:spcAft>
-                <a:spcPts val="400"/>
-              </a:spcAft>
-              <a:defRPr sz="1700" b="1">
-                <a:solidFill>
-                  <a:srgbClr val="4F46E5"/>
+                <a:spcPts val="300"/>
+              </a:spcAft>
+              <a:defRPr sz="1600" b="1">
+                <a:solidFill>
+                  <a:srgbClr val="0F172A"/>
                 </a:solidFill>
                 <a:latin typeface="Calibri"/>
               </a:defRPr>
             </a:pPr>
             <a:r>
-              <a:t>1. Agentic Core &amp; Reasoning Engine</a:t>
+              <a:t>LAYER 4: VISUAL DECISION STUDIO &amp; CLOUD ORCHESTRATION</a:t>
             </a:r>
           </a:p>
           <a:p>
             <a:pPr>
-              <a:defRPr sz="1350">
+              <a:spcAft>
+                <a:spcPts val="400"/>
+              </a:spcAft>
+              <a:defRPr sz="1300">
                 <a:solidFill>
                   <a:srgbClr val="334155"/>
                 </a:solidFill>
@@ -13740,220 +14430,27 @@
               </a:defRPr>
             </a:pPr>
             <a:r>
-              <a:t>Python 3.13 • Pydantic v2 Type-Safe Schemas • Dynamic Evidence Spec Planner • Gatekeeper Zero-Hallucination Auditor • Pluggable LLM (Groq Llama 3.3 70B / Gemini 1.5 Pro / Local)</a:t>
-            </a:r>
-          </a:p>
-        </p:txBody>
-      </p:sp>
-      <p:sp>
-        <p:nvSpPr>
-          <p:cNvPr id="136" name="Rounded Rectangle 135"/>
-          <p:cNvSpPr/>
-          <p:nvPr/>
-        </p:nvSpPr>
-        <p:spPr>
-          <a:xfrm>
-            <a:off x="1024128" y="4187952"/>
-            <a:ext cx="16239744" cy="1536192"/>
-          </a:xfrm>
-          <a:prstGeom prst="roundRect">
-            <a:avLst/>
-          </a:prstGeom>
-          <a:solidFill>
-            <a:srgbClr val="FFFFFF"/>
-          </a:solidFill>
-          <a:ln w="19050">
-            <a:solidFill>
-              <a:srgbClr val="CBD5E1"/>
-            </a:solidFill>
-          </a:ln>
-        </p:spPr>
-        <p:style>
-          <a:lnRef idx="1">
-            <a:schemeClr val="accent1"/>
-          </a:lnRef>
-          <a:fillRef idx="3">
-            <a:schemeClr val="accent1"/>
-          </a:fillRef>
-          <a:effectRef idx="2">
-            <a:schemeClr val="accent1"/>
-          </a:effectRef>
-          <a:fontRef idx="minor">
-            <a:schemeClr val="lt1"/>
-          </a:fontRef>
-        </p:style>
-        <p:txBody>
-          <a:bodyPr rtlCol="0" anchor="ctr" lIns="365760" rIns="365760" wrap="square"/>
-          <a:lstStyle/>
-          <a:p>
-            <a:pPr algn="ctr">
-              <a:spcAft>
-                <a:spcPts val="400"/>
-              </a:spcAft>
-              <a:defRPr sz="1700" b="1">
-                <a:solidFill>
-                  <a:srgbClr val="0D9488"/>
-                </a:solidFill>
-                <a:latin typeface="Calibri"/>
-              </a:defRPr>
-            </a:pPr>
-            <a:r>
-              <a:t>2. Autonomous Multi-Source Enterprise Connectors</a:t>
+              <a:t>Dark-Mode Visual Studio UI • 8-Step Interactive Pipeline Stepper • Turbo (&lt;50ms) &amp; Animated Execution Modes • Continuous Meta-Learning &amp; Process Mining Dashboard</a:t>
             </a:r>
           </a:p>
           <a:p>
-            <a:pPr>
-              <a:defRPr sz="1350">
-                <a:solidFill>
-                  <a:srgbClr val="334155"/>
+            <a:r>
+              <a:rPr sz="1200" b="1">
+                <a:solidFill>
+                  <a:srgbClr val="1E293B"/>
                 </a:solidFill>
                 <a:latin typeface="Calibri"/>
-              </a:defRPr>
-            </a:pPr>
-            <a:r>
-              <a:t>Corporate Google Drive Vault (Indexed PDFs, SOC2, Appraisals) • Mailbox Archive (Gmail / M365 Exchange Threads) • ERP Financial Ledger (NetSuite / SAP GL Balances) • Regulatory Registries (D&amp;B, OFAC, SOS)</a:t>
-            </a:r>
-          </a:p>
-        </p:txBody>
-      </p:sp>
-      <p:sp>
-        <p:nvSpPr>
-          <p:cNvPr id="137" name="Rounded Rectangle 136"/>
-          <p:cNvSpPr/>
-          <p:nvPr/>
-        </p:nvSpPr>
-        <p:spPr>
-          <a:xfrm>
-            <a:off x="1024128" y="5907024"/>
-            <a:ext cx="16239744" cy="1536192"/>
-          </a:xfrm>
-          <a:prstGeom prst="roundRect">
-            <a:avLst/>
-          </a:prstGeom>
-          <a:solidFill>
-            <a:srgbClr val="FFFFFF"/>
-          </a:solidFill>
-          <a:ln w="19050">
-            <a:solidFill>
-              <a:srgbClr val="CBD5E1"/>
-            </a:solidFill>
-          </a:ln>
-        </p:spPr>
-        <p:style>
-          <a:lnRef idx="1">
-            <a:schemeClr val="accent1"/>
-          </a:lnRef>
-          <a:fillRef idx="3">
-            <a:schemeClr val="accent1"/>
-          </a:fillRef>
-          <a:effectRef idx="2">
-            <a:schemeClr val="accent1"/>
-          </a:effectRef>
-          <a:fontRef idx="minor">
-            <a:schemeClr val="lt1"/>
-          </a:fontRef>
-        </p:style>
-        <p:txBody>
-          <a:bodyPr rtlCol="0" anchor="ctr" lIns="365760" rIns="365760" wrap="square"/>
-          <a:lstStyle/>
-          <a:p>
-            <a:pPr algn="ctr">
-              <a:spcAft>
-                <a:spcPts val="400"/>
-              </a:spcAft>
-              <a:defRPr sz="1700" b="1">
-                <a:solidFill>
-                  <a:srgbClr val="D97706"/>
+              </a:rPr>
+              <a:t>Tech Stack: </a:t>
+            </a:r>
+            <a:r>
+              <a:rPr sz="1200">
+                <a:solidFill>
+                  <a:srgbClr val="0F172A"/>
                 </a:solidFill>
                 <a:latin typeface="Calibri"/>
-              </a:defRPr>
-            </a:pPr>
-            <a:r>
-              <a:t>3. Precision Human-in-the-Loop &amp; Execution Dispatchers</a:t>
-            </a:r>
-          </a:p>
-          <a:p>
-            <a:pPr>
-              <a:defRPr sz="1350">
-                <a:solidFill>
-                  <a:srgbClr val="334155"/>
-                </a:solidFill>
-                <a:latin typeface="Calibri"/>
-              </a:defRPr>
-            </a:pPr>
-            <a:r>
-              <a:t>Precision Micro-Ask Orchestrator • Webhook Action Cards (Slack / Email 1-Click Interactive Buttons) • Downstream Action Dispatchers (PO Creation, EDI-835 Claims, Term Sheets) • SHA-256 Audit Ledger</a:t>
-            </a:r>
-          </a:p>
-        </p:txBody>
-      </p:sp>
-      <p:sp>
-        <p:nvSpPr>
-          <p:cNvPr id="138" name="Rounded Rectangle 137"/>
-          <p:cNvSpPr/>
-          <p:nvPr/>
-        </p:nvSpPr>
-        <p:spPr>
-          <a:xfrm>
-            <a:off x="1024128" y="7626096"/>
-            <a:ext cx="16239744" cy="1536192"/>
-          </a:xfrm>
-          <a:prstGeom prst="roundRect">
-            <a:avLst/>
-          </a:prstGeom>
-          <a:solidFill>
-            <a:srgbClr val="FFFFFF"/>
-          </a:solidFill>
-          <a:ln w="19050">
-            <a:solidFill>
-              <a:srgbClr val="CBD5E1"/>
-            </a:solidFill>
-          </a:ln>
-        </p:spPr>
-        <p:style>
-          <a:lnRef idx="1">
-            <a:schemeClr val="accent1"/>
-          </a:lnRef>
-          <a:fillRef idx="3">
-            <a:schemeClr val="accent1"/>
-          </a:fillRef>
-          <a:effectRef idx="2">
-            <a:schemeClr val="accent1"/>
-          </a:effectRef>
-          <a:fontRef idx="minor">
-            <a:schemeClr val="lt1"/>
-          </a:fontRef>
-        </p:style>
-        <p:txBody>
-          <a:bodyPr rtlCol="0" anchor="ctr" lIns="365760" rIns="365760" wrap="square"/>
-          <a:lstStyle/>
-          <a:p>
-            <a:pPr algn="ctr">
-              <a:spcAft>
-                <a:spcPts val="400"/>
-              </a:spcAft>
-              <a:defRPr sz="1700" b="1">
-                <a:solidFill>
-                  <a:srgbClr val="0F172A"/>
-                </a:solidFill>
-                <a:latin typeface="Calibri"/>
-              </a:defRPr>
-            </a:pPr>
-            <a:r>
-              <a:t>4. Visual Decision Studio, API &amp; Cloud Orchestration</a:t>
-            </a:r>
-          </a:p>
-          <a:p>
-            <a:pPr>
-              <a:defRPr sz="1350">
-                <a:solidFill>
-                  <a:srgbClr val="334155"/>
-                </a:solidFill>
-                <a:latin typeface="Calibri"/>
-              </a:defRPr>
-            </a:pPr>
-            <a:r>
-              <a:t>Modern Dark-Mode Decision Studio (Tailwind CSS, Lucide Icons) • High-Performance Flask/FastAPI REST API (&lt; 20ms execution) • Cloudflare Secure Global HTTPS Tunnel • Production-Ready n8n Workflow JSON</a:t>
+              </a:rPr>
+              <a:t>FastAPI / Flask Single-Roundtrip API • Tailwind CSS • n8n Workflow (`decision_completeness.json`) • Cloudflare Live Tunnel</a:t>
             </a:r>
           </a:p>
         </p:txBody>
@@ -14100,7 +14597,7 @@
           <a:lstStyle/>
           <a:p>
             <a:pPr>
-              <a:defRPr sz="8000" b="0">
+              <a:defRPr sz="8000">
                 <a:solidFill>
                   <a:srgbClr val="5DE0E6"/>
                 </a:solidFill>
@@ -14151,14 +14648,11 @@
           </a:fontRef>
         </p:style>
         <p:txBody>
-          <a:bodyPr rtlCol="0" anchor="t" lIns="365760" rIns="365760" tIns="365760" bIns="365760" wrap="square"/>
+          <a:bodyPr rtlCol="0" anchor="ctr" lIns="365760" tIns="228600"/>
           <a:lstStyle/>
           <a:p>
             <a:pPr algn="ctr">
-              <a:spcAft>
-                <a:spcPts val="1000"/>
-              </a:spcAft>
-              <a:defRPr sz="1800" b="1">
+              <a:defRPr sz="1700" b="1">
                 <a:solidFill>
                   <a:srgbClr val="0F172A"/>
                 </a:solidFill>
@@ -14166,279 +14660,909 @@
               </a:defRPr>
             </a:pPr>
             <a:r>
-              <a:t>END-TO-END AUTONOMOUS AGENT PIPELINE</a:t>
+              <a:t>AUTONOMOUS MULTI-AGENT DECISION PIPELINE &amp; FEEDBACK LOOP</a:t>
+            </a:r>
+          </a:p>
+        </p:txBody>
+      </p:sp>
+      <p:sp>
+        <p:nvSpPr>
+          <p:cNvPr id="143" name="Rounded Rectangle 142"/>
+          <p:cNvSpPr/>
+          <p:nvPr/>
+        </p:nvSpPr>
+        <p:spPr>
+          <a:xfrm>
+            <a:off x="1280160" y="3108960"/>
+            <a:ext cx="2423160" cy="1691640"/>
+          </a:xfrm>
+          <a:prstGeom prst="roundRect">
+            <a:avLst/>
+          </a:prstGeom>
+          <a:solidFill>
+            <a:srgbClr val="F8FAFC"/>
+          </a:solidFill>
+          <a:ln w="19050">
+            <a:solidFill>
+              <a:srgbClr val="CBD5E1"/>
+            </a:solidFill>
+          </a:ln>
+        </p:spPr>
+        <p:style>
+          <a:lnRef idx="1">
+            <a:schemeClr val="accent1"/>
+          </a:lnRef>
+          <a:fillRef idx="3">
+            <a:schemeClr val="accent1"/>
+          </a:fillRef>
+          <a:effectRef idx="2">
+            <a:schemeClr val="accent1"/>
+          </a:effectRef>
+          <a:fontRef idx="minor">
+            <a:schemeClr val="lt1"/>
+          </a:fontRef>
+        </p:style>
+        <p:txBody>
+          <a:bodyPr rtlCol="0" anchor="ctr" wrap="square"/>
+          <a:lstStyle/>
+          <a:p>
+            <a:pPr algn="ctr">
+              <a:spcAft>
+                <a:spcPts val="400"/>
+              </a:spcAft>
+              <a:defRPr sz="1400" b="1">
+                <a:solidFill>
+                  <a:srgbClr val="0F172A"/>
+                </a:solidFill>
+                <a:latin typeface="Calibri"/>
+              </a:defRPr>
+            </a:pPr>
+            <a:r>
+              <a:t>Step 1</a:t>
+            </a:r>
+            <a:br/>
+            <a:r>
+              <a:t>INTAKE</a:t>
+            </a:r>
+          </a:p>
+          <a:p>
+            <a:pPr algn="ctr">
+              <a:defRPr sz="1200">
+                <a:solidFill>
+                  <a:srgbClr val="334155"/>
+                </a:solidFill>
+                <a:latin typeface="Calibri"/>
+              </a:defRPr>
+            </a:pPr>
+            <a:r>
+              <a:t>Request Arrives</a:t>
+            </a:r>
+            <a:br/>
+            <a:r>
+              <a:t>(Form / Email / API)</a:t>
+            </a:r>
+          </a:p>
+        </p:txBody>
+      </p:sp>
+      <p:sp>
+        <p:nvSpPr>
+          <p:cNvPr id="144" name="Right Arrow 143"/>
+          <p:cNvSpPr/>
+          <p:nvPr/>
+        </p:nvSpPr>
+        <p:spPr>
+          <a:xfrm>
+            <a:off x="3794760" y="3794760"/>
+            <a:ext cx="502920" cy="320040"/>
+          </a:xfrm>
+          <a:prstGeom prst="rightArrow">
+            <a:avLst/>
+          </a:prstGeom>
+          <a:solidFill>
+            <a:srgbClr val="0D9488"/>
+          </a:solidFill>
+          <a:ln>
+            <a:noFill/>
+          </a:ln>
+        </p:spPr>
+        <p:style>
+          <a:lnRef idx="1">
+            <a:schemeClr val="accent1"/>
+          </a:lnRef>
+          <a:fillRef idx="3">
+            <a:schemeClr val="accent1"/>
+          </a:fillRef>
+          <a:effectRef idx="2">
+            <a:schemeClr val="accent1"/>
+          </a:effectRef>
+          <a:fontRef idx="minor">
+            <a:schemeClr val="lt1"/>
+          </a:fontRef>
+        </p:style>
+        <p:txBody>
+          <a:bodyPr rtlCol="0" anchor="ctr"/>
+          <a:lstStyle/>
+          <a:p>
+            <a:pPr algn="ctr"/>
+          </a:p>
+        </p:txBody>
+      </p:sp>
+      <p:sp>
+        <p:nvSpPr>
+          <p:cNvPr id="145" name="Rounded Rectangle 144"/>
+          <p:cNvSpPr/>
+          <p:nvPr/>
+        </p:nvSpPr>
+        <p:spPr>
+          <a:xfrm>
+            <a:off x="4389120" y="3108960"/>
+            <a:ext cx="2423160" cy="1691640"/>
+          </a:xfrm>
+          <a:prstGeom prst="roundRect">
+            <a:avLst/>
+          </a:prstGeom>
+          <a:solidFill>
+            <a:srgbClr val="EEF2FF"/>
+          </a:solidFill>
+          <a:ln w="19050">
+            <a:solidFill>
+              <a:srgbClr val="C7D2FE"/>
+            </a:solidFill>
+          </a:ln>
+        </p:spPr>
+        <p:style>
+          <a:lnRef idx="1">
+            <a:schemeClr val="accent1"/>
+          </a:lnRef>
+          <a:fillRef idx="3">
+            <a:schemeClr val="accent1"/>
+          </a:fillRef>
+          <a:effectRef idx="2">
+            <a:schemeClr val="accent1"/>
+          </a:effectRef>
+          <a:fontRef idx="minor">
+            <a:schemeClr val="lt1"/>
+          </a:fontRef>
+        </p:style>
+        <p:txBody>
+          <a:bodyPr rtlCol="0" anchor="ctr" wrap="square"/>
+          <a:lstStyle/>
+          <a:p>
+            <a:pPr algn="ctr">
+              <a:spcAft>
+                <a:spcPts val="400"/>
+              </a:spcAft>
+              <a:defRPr sz="1400" b="1">
+                <a:solidFill>
+                  <a:srgbClr val="4F46E5"/>
+                </a:solidFill>
+                <a:latin typeface="Calibri"/>
+              </a:defRPr>
+            </a:pPr>
+            <a:r>
+              <a:t>Step 2</a:t>
+            </a:r>
+            <a:br/>
+            <a:r>
+              <a:t>PLANNER</a:t>
+            </a:r>
+          </a:p>
+          <a:p>
+            <a:pPr algn="ctr">
+              <a:defRPr sz="1200">
+                <a:solidFill>
+                  <a:srgbClr val="334155"/>
+                </a:solidFill>
+                <a:latin typeface="Calibri"/>
+              </a:defRPr>
+            </a:pPr>
+            <a:r>
+              <a:t>Dynamic Spec</a:t>
+            </a:r>
+            <a:br/>
+            <a:r>
+              <a:t>Inference (Pydantic)</a:t>
+            </a:r>
+          </a:p>
+        </p:txBody>
+      </p:sp>
+      <p:sp>
+        <p:nvSpPr>
+          <p:cNvPr id="146" name="Right Arrow 145"/>
+          <p:cNvSpPr/>
+          <p:nvPr/>
+        </p:nvSpPr>
+        <p:spPr>
+          <a:xfrm>
+            <a:off x="6903720" y="3794760"/>
+            <a:ext cx="502920" cy="320040"/>
+          </a:xfrm>
+          <a:prstGeom prst="rightArrow">
+            <a:avLst/>
+          </a:prstGeom>
+          <a:solidFill>
+            <a:srgbClr val="0D9488"/>
+          </a:solidFill>
+          <a:ln>
+            <a:noFill/>
+          </a:ln>
+        </p:spPr>
+        <p:style>
+          <a:lnRef idx="1">
+            <a:schemeClr val="accent1"/>
+          </a:lnRef>
+          <a:fillRef idx="3">
+            <a:schemeClr val="accent1"/>
+          </a:fillRef>
+          <a:effectRef idx="2">
+            <a:schemeClr val="accent1"/>
+          </a:effectRef>
+          <a:fontRef idx="minor">
+            <a:schemeClr val="lt1"/>
+          </a:fontRef>
+        </p:style>
+        <p:txBody>
+          <a:bodyPr rtlCol="0" anchor="ctr"/>
+          <a:lstStyle/>
+          <a:p>
+            <a:pPr algn="ctr"/>
+          </a:p>
+        </p:txBody>
+      </p:sp>
+      <p:sp>
+        <p:nvSpPr>
+          <p:cNvPr id="147" name="Rounded Rectangle 146"/>
+          <p:cNvSpPr/>
+          <p:nvPr/>
+        </p:nvSpPr>
+        <p:spPr>
+          <a:xfrm>
+            <a:off x="7498080" y="3108960"/>
+            <a:ext cx="2423160" cy="1691640"/>
+          </a:xfrm>
+          <a:prstGeom prst="roundRect">
+            <a:avLst/>
+          </a:prstGeom>
+          <a:solidFill>
+            <a:srgbClr val="FEF2F2"/>
+          </a:solidFill>
+          <a:ln w="19050">
+            <a:solidFill>
+              <a:srgbClr val="FCA5A5"/>
+            </a:solidFill>
+          </a:ln>
+        </p:spPr>
+        <p:style>
+          <a:lnRef idx="1">
+            <a:schemeClr val="accent1"/>
+          </a:lnRef>
+          <a:fillRef idx="3">
+            <a:schemeClr val="accent1"/>
+          </a:fillRef>
+          <a:effectRef idx="2">
+            <a:schemeClr val="accent1"/>
+          </a:effectRef>
+          <a:fontRef idx="minor">
+            <a:schemeClr val="lt1"/>
+          </a:fontRef>
+        </p:style>
+        <p:txBody>
+          <a:bodyPr rtlCol="0" anchor="ctr" wrap="square"/>
+          <a:lstStyle/>
+          <a:p>
+            <a:pPr algn="ctr">
+              <a:spcAft>
+                <a:spcPts val="400"/>
+              </a:spcAft>
+              <a:defRPr sz="1400" b="1">
+                <a:solidFill>
+                  <a:srgbClr val="DC2626"/>
+                </a:solidFill>
+                <a:latin typeface="Calibri"/>
+              </a:defRPr>
+            </a:pPr>
+            <a:r>
+              <a:t>Step 3 &amp; 4</a:t>
+            </a:r>
+            <a:br/>
+            <a:r>
+              <a:t>AUDITOR</a:t>
+            </a:r>
+          </a:p>
+          <a:p>
+            <a:pPr algn="ctr">
+              <a:defRPr sz="1200">
+                <a:solidFill>
+                  <a:srgbClr val="334155"/>
+                </a:solidFill>
+                <a:latin typeface="Calibri"/>
+              </a:defRPr>
+            </a:pPr>
+            <a:r>
+              <a:t>Gap Audit &amp;</a:t>
+            </a:r>
+            <a:br/>
+            <a:r>
+              <a:t>Gatekeeper Block</a:t>
+            </a:r>
+          </a:p>
+        </p:txBody>
+      </p:sp>
+      <p:sp>
+        <p:nvSpPr>
+          <p:cNvPr id="148" name="Right Arrow 147"/>
+          <p:cNvSpPr/>
+          <p:nvPr/>
+        </p:nvSpPr>
+        <p:spPr>
+          <a:xfrm>
+            <a:off x="10012680" y="3794760"/>
+            <a:ext cx="502920" cy="320040"/>
+          </a:xfrm>
+          <a:prstGeom prst="rightArrow">
+            <a:avLst/>
+          </a:prstGeom>
+          <a:solidFill>
+            <a:srgbClr val="0D9488"/>
+          </a:solidFill>
+          <a:ln>
+            <a:noFill/>
+          </a:ln>
+        </p:spPr>
+        <p:style>
+          <a:lnRef idx="1">
+            <a:schemeClr val="accent1"/>
+          </a:lnRef>
+          <a:fillRef idx="3">
+            <a:schemeClr val="accent1"/>
+          </a:fillRef>
+          <a:effectRef idx="2">
+            <a:schemeClr val="accent1"/>
+          </a:effectRef>
+          <a:fontRef idx="minor">
+            <a:schemeClr val="lt1"/>
+          </a:fontRef>
+        </p:style>
+        <p:txBody>
+          <a:bodyPr rtlCol="0" anchor="ctr"/>
+          <a:lstStyle/>
+          <a:p>
+            <a:pPr algn="ctr"/>
+          </a:p>
+        </p:txBody>
+      </p:sp>
+      <p:sp>
+        <p:nvSpPr>
+          <p:cNvPr id="149" name="Rounded Rectangle 148"/>
+          <p:cNvSpPr/>
+          <p:nvPr/>
+        </p:nvSpPr>
+        <p:spPr>
+          <a:xfrm>
+            <a:off x="10607040" y="3108960"/>
+            <a:ext cx="2423160" cy="1691640"/>
+          </a:xfrm>
+          <a:prstGeom prst="roundRect">
+            <a:avLst/>
+          </a:prstGeom>
+          <a:solidFill>
+            <a:srgbClr val="F0FDFA"/>
+          </a:solidFill>
+          <a:ln w="19050">
+            <a:solidFill>
+              <a:srgbClr val="5EEAD4"/>
+            </a:solidFill>
+          </a:ln>
+        </p:spPr>
+        <p:style>
+          <a:lnRef idx="1">
+            <a:schemeClr val="accent1"/>
+          </a:lnRef>
+          <a:fillRef idx="3">
+            <a:schemeClr val="accent1"/>
+          </a:fillRef>
+          <a:effectRef idx="2">
+            <a:schemeClr val="accent1"/>
+          </a:effectRef>
+          <a:fontRef idx="minor">
+            <a:schemeClr val="lt1"/>
+          </a:fontRef>
+        </p:style>
+        <p:txBody>
+          <a:bodyPr rtlCol="0" anchor="ctr" wrap="square"/>
+          <a:lstStyle/>
+          <a:p>
+            <a:pPr algn="ctr">
+              <a:spcAft>
+                <a:spcPts val="400"/>
+              </a:spcAft>
+              <a:defRPr sz="1400" b="1">
+                <a:solidFill>
+                  <a:srgbClr val="0D9488"/>
+                </a:solidFill>
+                <a:latin typeface="Calibri"/>
+              </a:defRPr>
+            </a:pPr>
+            <a:r>
+              <a:t>Step 5</a:t>
+            </a:r>
+            <a:br/>
+            <a:r>
+              <a:t>RETRIEVER</a:t>
+            </a:r>
+          </a:p>
+          <a:p>
+            <a:pPr algn="ctr">
+              <a:defRPr sz="1200">
+                <a:solidFill>
+                  <a:srgbClr val="334155"/>
+                </a:solidFill>
+                <a:latin typeface="Calibri"/>
+              </a:defRPr>
+            </a:pPr>
+            <a:r>
+              <a:t>Autonomous Search</a:t>
+            </a:r>
+            <a:br/>
+            <a:r>
+              <a:t>(Drive/Mail/ERP)</a:t>
+            </a:r>
+          </a:p>
+        </p:txBody>
+      </p:sp>
+      <p:sp>
+        <p:nvSpPr>
+          <p:cNvPr id="150" name="Right Arrow 149"/>
+          <p:cNvSpPr/>
+          <p:nvPr/>
+        </p:nvSpPr>
+        <p:spPr>
+          <a:xfrm>
+            <a:off x="13121640" y="3794760"/>
+            <a:ext cx="502920" cy="320040"/>
+          </a:xfrm>
+          <a:prstGeom prst="rightArrow">
+            <a:avLst/>
+          </a:prstGeom>
+          <a:solidFill>
+            <a:srgbClr val="0D9488"/>
+          </a:solidFill>
+          <a:ln>
+            <a:noFill/>
+          </a:ln>
+        </p:spPr>
+        <p:style>
+          <a:lnRef idx="1">
+            <a:schemeClr val="accent1"/>
+          </a:lnRef>
+          <a:fillRef idx="3">
+            <a:schemeClr val="accent1"/>
+          </a:fillRef>
+          <a:effectRef idx="2">
+            <a:schemeClr val="accent1"/>
+          </a:effectRef>
+          <a:fontRef idx="minor">
+            <a:schemeClr val="lt1"/>
+          </a:fontRef>
+        </p:style>
+        <p:txBody>
+          <a:bodyPr rtlCol="0" anchor="ctr"/>
+          <a:lstStyle/>
+          <a:p>
+            <a:pPr algn="ctr"/>
+          </a:p>
+        </p:txBody>
+      </p:sp>
+      <p:sp>
+        <p:nvSpPr>
+          <p:cNvPr id="151" name="Rounded Rectangle 150"/>
+          <p:cNvSpPr/>
+          <p:nvPr/>
+        </p:nvSpPr>
+        <p:spPr>
+          <a:xfrm>
+            <a:off x="13716000" y="3108960"/>
+            <a:ext cx="2423160" cy="1691640"/>
+          </a:xfrm>
+          <a:prstGeom prst="roundRect">
+            <a:avLst/>
+          </a:prstGeom>
+          <a:solidFill>
+            <a:srgbClr val="FEF3C7"/>
+          </a:solidFill>
+          <a:ln w="19050">
+            <a:solidFill>
+              <a:srgbClr val="FCD34D"/>
+            </a:solidFill>
+          </a:ln>
+        </p:spPr>
+        <p:style>
+          <a:lnRef idx="1">
+            <a:schemeClr val="accent1"/>
+          </a:lnRef>
+          <a:fillRef idx="3">
+            <a:schemeClr val="accent1"/>
+          </a:fillRef>
+          <a:effectRef idx="2">
+            <a:schemeClr val="accent1"/>
+          </a:effectRef>
+          <a:fontRef idx="minor">
+            <a:schemeClr val="lt1"/>
+          </a:fontRef>
+        </p:style>
+        <p:txBody>
+          <a:bodyPr rtlCol="0" anchor="ctr" wrap="square"/>
+          <a:lstStyle/>
+          <a:p>
+            <a:pPr algn="ctr">
+              <a:spcAft>
+                <a:spcPts val="400"/>
+              </a:spcAft>
+              <a:defRPr sz="1400" b="1">
+                <a:solidFill>
+                  <a:srgbClr val="D97706"/>
+                </a:solidFill>
+                <a:latin typeface="Calibri"/>
+              </a:defRPr>
+            </a:pPr>
+            <a:r>
+              <a:t>Step 6</a:t>
+            </a:r>
+            <a:br/>
+            <a:r>
+              <a:t>HITL MICRO-ASK</a:t>
+            </a:r>
+          </a:p>
+          <a:p>
+            <a:pPr algn="ctr">
+              <a:defRPr sz="1200">
+                <a:solidFill>
+                  <a:srgbClr val="334155"/>
+                </a:solidFill>
+                <a:latin typeface="Calibri"/>
+              </a:defRPr>
+            </a:pPr>
+            <a:r>
+              <a:t>Targeted 1-Click</a:t>
+            </a:r>
+            <a:br/>
+            <a:r>
+              <a:t>Slack Approval</a:t>
+            </a:r>
+          </a:p>
+        </p:txBody>
+      </p:sp>
+      <p:sp>
+        <p:nvSpPr>
+          <p:cNvPr id="152" name="Rounded Rectangle 151"/>
+          <p:cNvSpPr/>
+          <p:nvPr/>
+        </p:nvSpPr>
+        <p:spPr>
+          <a:xfrm>
+            <a:off x="1280160" y="5120640"/>
+            <a:ext cx="9875520" cy="2103120"/>
+          </a:xfrm>
+          <a:prstGeom prst="roundRect">
+            <a:avLst/>
+          </a:prstGeom>
+          <a:solidFill>
+            <a:srgbClr val="F0FDF4"/>
+          </a:solidFill>
+          <a:ln w="19050">
+            <a:solidFill>
+              <a:srgbClr val="86EFAC"/>
+            </a:solidFill>
+          </a:ln>
+        </p:spPr>
+        <p:style>
+          <a:lnRef idx="1">
+            <a:schemeClr val="accent1"/>
+          </a:lnRef>
+          <a:fillRef idx="3">
+            <a:schemeClr val="accent1"/>
+          </a:fillRef>
+          <a:effectRef idx="2">
+            <a:schemeClr val="accent1"/>
+          </a:effectRef>
+          <a:fontRef idx="minor">
+            <a:schemeClr val="lt1"/>
+          </a:fontRef>
+        </p:style>
+        <p:txBody>
+          <a:bodyPr rtlCol="0" anchor="ctr" lIns="320040" rIns="320040" tIns="228600" wrap="square"/>
+          <a:lstStyle/>
+          <a:p>
+            <a:pPr algn="ctr">
+              <a:spcAft>
+                <a:spcPts val="400"/>
+              </a:spcAft>
+              <a:defRPr sz="1500" b="1">
+                <a:solidFill>
+                  <a:srgbClr val="16A34A"/>
+                </a:solidFill>
+                <a:latin typeface="Calibri"/>
+              </a:defRPr>
+            </a:pPr>
+            <a:r>
+              <a:t>Step 7: DELIBERATION, CONFIDENCE SCORING &amp; EXECUTION</a:t>
             </a:r>
           </a:p>
           <a:p>
             <a:pPr>
               <a:spcAft>
-                <a:spcPts val="700"/>
+                <a:spcPts val="300"/>
               </a:spcAft>
             </a:pPr>
             <a:r>
-              <a:rPr sz="1350" b="1">
+              <a:rPr sz="1200" b="1">
                 <a:solidFill>
                   <a:srgbClr val="0F172A"/>
                 </a:solidFill>
                 <a:latin typeface="Calibri"/>
               </a:rPr>
-              <a:t>[1] REQUEST INTAKE  </a:t>
-            </a:r>
-            <a:r>
-              <a:rPr sz="1150" b="1">
-                <a:solidFill>
-                  <a:srgbClr val="64748B"/>
+              <a:t>✓ Calibrated Verdict: </a:t>
+            </a:r>
+            <a:r>
+              <a:rPr sz="1200">
+                <a:solidFill>
+                  <a:srgbClr val="334155"/>
                 </a:solidFill>
                 <a:latin typeface="Calibri"/>
               </a:rPr>
-              <a:t>[Dossier Model]  —  </a:t>
-            </a:r>
-            <a:r>
-              <a:rPr sz="1300">
-                <a:solidFill>
-                  <a:srgbClr val="334155"/>
-                </a:solidFill>
-                <a:latin typeface="Calibri"/>
-              </a:rPr>
-              <a:t>Ingests transaction from Form, Email, Webhook, or API</a:t>
+              <a:t>Computes evidence-grounded confidence (e.g. 97%) and generates citation-backed explanation.</a:t>
             </a:r>
           </a:p>
           <a:p>
             <a:pPr>
               <a:spcAft>
-                <a:spcPts val="700"/>
+                <a:spcPts val="300"/>
               </a:spcAft>
             </a:pPr>
             <a:r>
-              <a:rPr sz="1350" b="1">
-                <a:solidFill>
-                  <a:srgbClr val="4F46E5"/>
+              <a:rPr sz="1200" b="1">
+                <a:solidFill>
+                  <a:srgbClr val="0F172A"/>
                 </a:solidFill>
                 <a:latin typeface="Calibri"/>
               </a:rPr>
-              <a:t>[2] EVIDENCE PLANNER  </a:t>
-            </a:r>
-            <a:r>
-              <a:rPr sz="1150" b="1">
-                <a:solidFill>
-                  <a:srgbClr val="64748B"/>
+              <a:t>✓ Automated Actions: </a:t>
+            </a:r>
+            <a:r>
+              <a:rPr sz="1200">
+                <a:solidFill>
+                  <a:srgbClr val="334155"/>
                 </a:solidFill>
                 <a:latin typeface="Calibri"/>
               </a:rPr>
-              <a:t>[Pydantic Spec]  —  </a:t>
-            </a:r>
-            <a:r>
-              <a:rPr sz="1300">
-                <a:solidFill>
-                  <a:srgbClr val="334155"/>
-                </a:solidFill>
-                <a:latin typeface="Calibri"/>
-              </a:rPr>
-              <a:t>LLM dynamically infers required evidence spec &amp; confidence thresholds</a:t>
+              <a:t>Generates Purchase Order PO-88421, updates NetSuite ERP, and dispatches Slack notifications.</a:t>
             </a:r>
           </a:p>
           <a:p>
             <a:pPr>
               <a:spcAft>
-                <a:spcPts val="700"/>
+                <a:spcPts val="300"/>
               </a:spcAft>
             </a:pPr>
             <a:r>
-              <a:rPr sz="1350" b="1">
-                <a:solidFill>
-                  <a:srgbClr val="DC2626"/>
+              <a:rPr sz="1200" b="1">
+                <a:solidFill>
+                  <a:srgbClr val="0F172A"/>
                 </a:solidFill>
                 <a:latin typeface="Calibri"/>
               </a:rPr>
-              <a:t>[3] GAP AUDITOR &amp; GATEKEEPER  </a:t>
-            </a:r>
-            <a:r>
-              <a:rPr sz="1150" b="1">
-                <a:solidFill>
-                  <a:srgbClr val="64748B"/>
+              <a:t>✓ Proof of Compliance: </a:t>
+            </a:r>
+            <a:r>
+              <a:rPr sz="1200">
+                <a:solidFill>
+                  <a:srgbClr val="334155"/>
                 </a:solidFill>
                 <a:latin typeface="Calibri"/>
               </a:rPr>
-              <a:t>[Zero-Hallucination Gate]  —  </a:t>
-            </a:r>
-            <a:r>
-              <a:rPr sz="1300">
-                <a:solidFill>
-                  <a:srgbClr val="334155"/>
+              <a:t>Commits SHA-256 cryptographic chain-of-custody audit log for zero-tamper auditability.</a:t>
+            </a:r>
+          </a:p>
+        </p:txBody>
+      </p:sp>
+      <p:sp>
+        <p:nvSpPr>
+          <p:cNvPr id="153" name="Rounded Rectangle 152"/>
+          <p:cNvSpPr/>
+          <p:nvPr/>
+        </p:nvSpPr>
+        <p:spPr>
+          <a:xfrm>
+            <a:off x="11521440" y="5120640"/>
+            <a:ext cx="5394960" cy="2103120"/>
+          </a:xfrm>
+          <a:prstGeom prst="roundRect">
+            <a:avLst/>
+          </a:prstGeom>
+          <a:solidFill>
+            <a:srgbClr val="EEF2FF"/>
+          </a:solidFill>
+          <a:ln w="19050">
+            <a:solidFill>
+              <a:srgbClr val="C7D2FE"/>
+            </a:solidFill>
+          </a:ln>
+        </p:spPr>
+        <p:style>
+          <a:lnRef idx="1">
+            <a:schemeClr val="accent1"/>
+          </a:lnRef>
+          <a:fillRef idx="3">
+            <a:schemeClr val="accent1"/>
+          </a:fillRef>
+          <a:effectRef idx="2">
+            <a:schemeClr val="accent1"/>
+          </a:effectRef>
+          <a:fontRef idx="minor">
+            <a:schemeClr val="lt1"/>
+          </a:fontRef>
+        </p:style>
+        <p:txBody>
+          <a:bodyPr rtlCol="0" anchor="ctr" lIns="274320" rIns="274320" tIns="228600" wrap="square"/>
+          <a:lstStyle/>
+          <a:p>
+            <a:pPr algn="ctr">
+              <a:spcAft>
+                <a:spcPts val="400"/>
+              </a:spcAft>
+              <a:defRPr sz="1500" b="1">
+                <a:solidFill>
+                  <a:srgbClr val="4F46E5"/>
                 </a:solidFill>
                 <a:latin typeface="Calibri"/>
-              </a:rPr>
-              <a:t>Audits available vs required evidence. If gaps exist: HALT &amp; ENGAGE GATE</a:t>
+              </a:defRPr>
+            </a:pPr>
+            <a:r>
+              <a:t>Step 8: META-LEARNING ENGINE</a:t>
             </a:r>
           </a:p>
           <a:p>
             <a:pPr>
               <a:spcAft>
-                <a:spcPts val="700"/>
+                <a:spcPts val="300"/>
               </a:spcAft>
             </a:pPr>
             <a:r>
-              <a:rPr sz="1350" b="1">
-                <a:solidFill>
-                  <a:srgbClr val="0D9488"/>
+              <a:rPr sz="1150" b="1">
+                <a:solidFill>
+                  <a:srgbClr val="0F172A"/>
                 </a:solidFill>
                 <a:latin typeface="Calibri"/>
               </a:rPr>
-              <a:t>[4] AUTONOMOUS RETRIEVER  </a:t>
-            </a:r>
-            <a:r>
-              <a:rPr sz="1150" b="1">
-                <a:solidFill>
-                  <a:srgbClr val="64748B"/>
+              <a:t>• Telemetry Mining: </a:t>
+            </a:r>
+            <a:r>
+              <a:rPr sz="1150">
+                <a:solidFill>
+                  <a:srgbClr val="334155"/>
                 </a:solidFill>
                 <a:latin typeface="Calibri"/>
               </a:rPr>
-              <a:t>[Multi-Source Search]  —  </a:t>
-            </a:r>
-            <a:r>
-              <a:rPr sz="1300">
-                <a:solidFill>
-                  <a:srgbClr val="334155"/>
-                </a:solidFill>
-                <a:latin typeface="Calibri"/>
-              </a:rPr>
-              <a:t>Searches Google Drive Vault, Gmail/M365, NetSuite ERP, Registries</a:t>
+              <a:t>Aggregates recurring missing evidence patterns across all past decisions.</a:t>
             </a:r>
           </a:p>
           <a:p>
             <a:pPr>
               <a:spcAft>
-                <a:spcPts val="700"/>
+                <a:spcPts val="300"/>
               </a:spcAft>
             </a:pPr>
             <a:r>
-              <a:rPr sz="1350" b="1">
-                <a:solidFill>
-                  <a:srgbClr val="D97706"/>
+              <a:rPr sz="1150" b="1">
+                <a:solidFill>
+                  <a:srgbClr val="0F172A"/>
                 </a:solidFill>
                 <a:latin typeface="Calibri"/>
               </a:rPr>
-              <a:t>[5] PRECISION HITL MICRO-ASK  </a:t>
-            </a:r>
-            <a:r>
-              <a:rPr sz="1150" b="1">
-                <a:solidFill>
-                  <a:srgbClr val="64748B"/>
+              <a:t>• Intake Optimization: </a:t>
+            </a:r>
+            <a:r>
+              <a:rPr sz="1150">
+                <a:solidFill>
+                  <a:srgbClr val="334155"/>
                 </a:solidFill>
                 <a:latin typeface="Calibri"/>
               </a:rPr>
-              <a:t>[1-Click Interactive Card]  —  </a:t>
-            </a:r>
-            <a:r>
-              <a:rPr sz="1300">
-                <a:solidFill>
-                  <a:srgbClr val="334155"/>
-                </a:solidFill>
-                <a:latin typeface="Calibri"/>
-              </a:rPr>
-              <a:t>Dispatches surgical Slack/Email card for ONLY the remaining missing delta</a:t>
+              <a:t>Suggests: '70% of delays are missing budget sign-off. Add budget check at intake form.'</a:t>
             </a:r>
           </a:p>
           <a:p>
             <a:pPr>
               <a:spcAft>
-                <a:spcPts val="700"/>
+                <a:spcPts val="300"/>
               </a:spcAft>
             </a:pPr>
             <a:r>
-              <a:rPr sz="1350" b="1">
-                <a:solidFill>
-                  <a:srgbClr val="16A34A"/>
+              <a:rPr sz="1150" b="1">
+                <a:solidFill>
+                  <a:srgbClr val="0F172A"/>
                 </a:solidFill>
                 <a:latin typeface="Calibri"/>
               </a:rPr>
-              <a:t>[6] DELIBERATOR &amp; VERDICT  </a:t>
-            </a:r>
-            <a:r>
-              <a:rPr sz="1150" b="1">
-                <a:solidFill>
-                  <a:srgbClr val="64748B"/>
+              <a:t>• Continuous ROI: </a:t>
+            </a:r>
+            <a:r>
+              <a:rPr sz="1150">
+                <a:solidFill>
+                  <a:srgbClr val="334155"/>
                 </a:solidFill>
                 <a:latin typeface="Calibri"/>
               </a:rPr>
-              <a:t>[Explainable Verdict]  —  </a:t>
-            </a:r>
-            <a:r>
-              <a:rPr sz="1300">
-                <a:solidFill>
-                  <a:srgbClr val="334155"/>
+              <a:t>Turns organizational decision bottlenecks into permanent process upgrades.</a:t>
+            </a:r>
+          </a:p>
+        </p:txBody>
+      </p:sp>
+      <p:sp>
+        <p:nvSpPr>
+          <p:cNvPr id="154" name="Rounded Rectangle 153"/>
+          <p:cNvSpPr/>
+          <p:nvPr/>
+        </p:nvSpPr>
+        <p:spPr>
+          <a:xfrm>
+            <a:off x="1280160" y="7498079"/>
+            <a:ext cx="15636240" cy="1371600"/>
+          </a:xfrm>
+          <a:prstGeom prst="roundRect">
+            <a:avLst/>
+          </a:prstGeom>
+          <a:solidFill>
+            <a:srgbClr val="0F172A"/>
+          </a:solidFill>
+          <a:ln>
+            <a:noFill/>
+          </a:ln>
+        </p:spPr>
+        <p:style>
+          <a:lnRef idx="1">
+            <a:schemeClr val="accent1"/>
+          </a:lnRef>
+          <a:fillRef idx="3">
+            <a:schemeClr val="accent1"/>
+          </a:fillRef>
+          <a:effectRef idx="2">
+            <a:schemeClr val="accent1"/>
+          </a:effectRef>
+          <a:fontRef idx="minor">
+            <a:schemeClr val="lt1"/>
+          </a:fontRef>
+        </p:style>
+        <p:txBody>
+          <a:bodyPr rtlCol="0" anchor="ctr" lIns="365760" rIns="365760"/>
+          <a:lstStyle/>
+          <a:p>
+            <a:pPr algn="ctr">
+              <a:spcAft>
+                <a:spcPts val="200"/>
+              </a:spcAft>
+              <a:defRPr sz="1300" b="1">
+                <a:solidFill>
+                  <a:srgbClr val="5DE0E6"/>
                 </a:solidFill>
                 <a:latin typeface="Calibri"/>
-              </a:rPr>
-              <a:t>Holistic synthesis, calibrated confidence (e.g. 97%), citation-backed reasoning</a:t>
+              </a:defRPr>
+            </a:pPr>
+            <a:r>
+              <a:t>ENTERPRISE SECURITY &amp; COMPLIANCE ARCHITECTURE</a:t>
             </a:r>
           </a:p>
           <a:p>
             <a:pPr>
-              <a:spcAft>
-                <a:spcPts val="700"/>
-              </a:spcAft>
+              <a:defRPr sz="1200">
+                <a:solidFill>
+                  <a:srgbClr val="FFFFFF"/>
+                </a:solidFill>
+                <a:latin typeface="Calibri"/>
+              </a:defRPr>
             </a:pPr>
             <a:r>
-              <a:rPr sz="1350" b="1">
-                <a:solidFill>
-                  <a:srgbClr val="4F46E5"/>
-                </a:solidFill>
-                <a:latin typeface="Calibri"/>
-              </a:rPr>
-              <a:t>[7] DOWNSTREAM ACTIONS  </a:t>
-            </a:r>
-            <a:r>
-              <a:rPr sz="1150" b="1">
-                <a:solidFill>
-                  <a:srgbClr val="64748B"/>
-                </a:solidFill>
-                <a:latin typeface="Calibri"/>
-              </a:rPr>
-              <a:t>[Automated Execution]  —  </a:t>
-            </a:r>
-            <a:r>
-              <a:rPr sz="1300">
-                <a:solidFill>
-                  <a:srgbClr val="334155"/>
-                </a:solidFill>
-                <a:latin typeface="Calibri"/>
-              </a:rPr>
-              <a:t>Dispatches PO creation, sends notifications, commits SHA-256 audit ledger</a:t>
-            </a:r>
-          </a:p>
-          <a:p>
-            <a:pPr>
-              <a:spcAft>
-                <a:spcPts val="700"/>
-              </a:spcAft>
-            </a:pPr>
-            <a:r>
-              <a:rPr sz="1350" b="1">
-                <a:solidFill>
-                  <a:srgbClr val="0F172A"/>
-                </a:solidFill>
-                <a:latin typeface="Calibri"/>
-              </a:rPr>
-              <a:t>[8] META-LEARNING OPTIMIZER  </a:t>
-            </a:r>
-            <a:r>
-              <a:rPr sz="1150" b="1">
-                <a:solidFill>
-                  <a:srgbClr val="64748B"/>
-                </a:solidFill>
-                <a:latin typeface="Calibri"/>
-              </a:rPr>
-              <a:t>[Continuous Optimization]  —  </a:t>
-            </a:r>
-            <a:r>
-              <a:rPr sz="1300">
-                <a:solidFill>
-                  <a:srgbClr val="334155"/>
-                </a:solidFill>
-                <a:latin typeface="Calibri"/>
-              </a:rPr>
-              <a:t>Telemetry mines blocker patterns; proposes intake form re-engineering</a:t>
+              <a:t>• Zero Data Retention Covenant • SOC2 Type II Encrypted Connectors • Least-Privilege Role-Based Access Control (RBAC) • SHA-256 Cryptographic Audit Ledger</a:t>
             </a:r>
           </a:p>
         </p:txBody>
@@ -14653,14 +15777,11 @@
           </a:fontRef>
         </p:style>
         <p:txBody>
-          <a:bodyPr rtlCol="0" anchor="t" lIns="365760" rIns="365760" tIns="365760" bIns="365760" wrap="square"/>
+          <a:bodyPr rtlCol="0" anchor="ctr" lIns="365760" tIns="182880"/>
           <a:lstStyle/>
           <a:p>
             <a:pPr algn="ctr">
-              <a:spcAft>
-                <a:spcPts val="1200"/>
-              </a:spcAft>
-              <a:defRPr sz="1800" b="1">
+              <a:defRPr sz="1700" b="1">
                 <a:solidFill>
                   <a:srgbClr val="0F172A"/>
                 </a:solidFill>
@@ -14668,182 +15789,744 @@
               </a:defRPr>
             </a:pPr>
             <a:r>
-              <a:t>THE 8-STEP AUTONOMOUS DECISION LIFECYCLE</a:t>
+              <a:t>DATA FLOW DIAGRAM (DFD LEVEL-1): EVIDENCE COMPLETENESS LIFECYCLE</a:t>
+            </a:r>
+          </a:p>
+        </p:txBody>
+      </p:sp>
+      <p:sp>
+        <p:nvSpPr>
+          <p:cNvPr id="149" name="Rounded Rectangle 148"/>
+          <p:cNvSpPr/>
+          <p:nvPr/>
+        </p:nvSpPr>
+        <p:spPr>
+          <a:xfrm>
+            <a:off x="1280160" y="3291840"/>
+            <a:ext cx="2743200" cy="1371600"/>
+          </a:xfrm>
+          <a:prstGeom prst="roundRect">
+            <a:avLst/>
+          </a:prstGeom>
+          <a:solidFill>
+            <a:srgbClr val="0F172A"/>
+          </a:solidFill>
+          <a:ln>
+            <a:noFill/>
+          </a:ln>
+        </p:spPr>
+        <p:style>
+          <a:lnRef idx="1">
+            <a:schemeClr val="accent1"/>
+          </a:lnRef>
+          <a:fillRef idx="3">
+            <a:schemeClr val="accent1"/>
+          </a:fillRef>
+          <a:effectRef idx="2">
+            <a:schemeClr val="accent1"/>
+          </a:effectRef>
+          <a:fontRef idx="minor">
+            <a:schemeClr val="lt1"/>
+          </a:fontRef>
+        </p:style>
+        <p:txBody>
+          <a:bodyPr rtlCol="0" anchor="ctr" wrap="square"/>
+          <a:lstStyle/>
+          <a:p>
+            <a:pPr algn="ctr">
+              <a:defRPr sz="1400" b="1">
+                <a:solidFill>
+                  <a:srgbClr val="FFFFFF"/>
+                </a:solidFill>
+                <a:latin typeface="Calibri"/>
+              </a:defRPr>
+            </a:pPr>
+            <a:r>
+              <a:t>EXTERNAL ENTITY</a:t>
+            </a:r>
+            <a:br/>
+            <a:r>
+              <a:t>Requester / Webhook</a:t>
+            </a:r>
+          </a:p>
+        </p:txBody>
+      </p:sp>
+      <p:sp>
+        <p:nvSpPr>
+          <p:cNvPr id="150" name="Right Arrow 149"/>
+          <p:cNvSpPr/>
+          <p:nvPr/>
+        </p:nvSpPr>
+        <p:spPr>
+          <a:xfrm>
+            <a:off x="4114800" y="3794760"/>
+            <a:ext cx="548640" cy="365760"/>
+          </a:xfrm>
+          <a:prstGeom prst="rightArrow">
+            <a:avLst/>
+          </a:prstGeom>
+          <a:solidFill>
+            <a:srgbClr val="0D9488"/>
+          </a:solidFill>
+          <a:ln>
+            <a:noFill/>
+          </a:ln>
+        </p:spPr>
+        <p:style>
+          <a:lnRef idx="1">
+            <a:schemeClr val="accent1"/>
+          </a:lnRef>
+          <a:fillRef idx="3">
+            <a:schemeClr val="accent1"/>
+          </a:fillRef>
+          <a:effectRef idx="2">
+            <a:schemeClr val="accent1"/>
+          </a:effectRef>
+          <a:fontRef idx="minor">
+            <a:schemeClr val="lt1"/>
+          </a:fontRef>
+        </p:style>
+        <p:txBody>
+          <a:bodyPr rtlCol="0" anchor="ctr"/>
+          <a:lstStyle/>
+          <a:p>
+            <a:pPr algn="ctr"/>
+          </a:p>
+        </p:txBody>
+      </p:sp>
+      <p:sp>
+        <p:nvSpPr>
+          <p:cNvPr id="151" name="Rounded Rectangle 150"/>
+          <p:cNvSpPr/>
+          <p:nvPr/>
+        </p:nvSpPr>
+        <p:spPr>
+          <a:xfrm>
+            <a:off x="4754880" y="3108960"/>
+            <a:ext cx="3108960" cy="1737360"/>
+          </a:xfrm>
+          <a:prstGeom prst="roundRect">
+            <a:avLst/>
+          </a:prstGeom>
+          <a:solidFill>
+            <a:srgbClr val="EEF2FF"/>
+          </a:solidFill>
+          <a:ln w="19050">
+            <a:solidFill>
+              <a:srgbClr val="C7D2FE"/>
+            </a:solidFill>
+          </a:ln>
+        </p:spPr>
+        <p:style>
+          <a:lnRef idx="1">
+            <a:schemeClr val="accent1"/>
+          </a:lnRef>
+          <a:fillRef idx="3">
+            <a:schemeClr val="accent1"/>
+          </a:fillRef>
+          <a:effectRef idx="2">
+            <a:schemeClr val="accent1"/>
+          </a:effectRef>
+          <a:fontRef idx="minor">
+            <a:schemeClr val="lt1"/>
+          </a:fontRef>
+        </p:style>
+        <p:txBody>
+          <a:bodyPr rtlCol="0" anchor="ctr" wrap="square"/>
+          <a:lstStyle/>
+          <a:p>
+            <a:pPr algn="ctr">
+              <a:defRPr sz="1300" b="1">
+                <a:solidFill>
+                  <a:srgbClr val="4F46E5"/>
+                </a:solidFill>
+                <a:latin typeface="Calibri"/>
+              </a:defRPr>
+            </a:pPr>
+            <a:r>
+              <a:t>Process 1.0</a:t>
+            </a:r>
+            <a:br/>
+            <a:r>
+              <a:t>EVIDENCE SPEC PLANNER</a:t>
+            </a:r>
+            <a:br/>
+            <a:r>
+              <a:t>(Infers Required Spec Items)</a:t>
+            </a:r>
+          </a:p>
+        </p:txBody>
+      </p:sp>
+      <p:sp>
+        <p:nvSpPr>
+          <p:cNvPr id="152" name="Right Arrow 151"/>
+          <p:cNvSpPr/>
+          <p:nvPr/>
+        </p:nvSpPr>
+        <p:spPr>
+          <a:xfrm>
+            <a:off x="7955279" y="3794760"/>
+            <a:ext cx="548640" cy="365760"/>
+          </a:xfrm>
+          <a:prstGeom prst="rightArrow">
+            <a:avLst/>
+          </a:prstGeom>
+          <a:solidFill>
+            <a:srgbClr val="0D9488"/>
+          </a:solidFill>
+          <a:ln>
+            <a:noFill/>
+          </a:ln>
+        </p:spPr>
+        <p:style>
+          <a:lnRef idx="1">
+            <a:schemeClr val="accent1"/>
+          </a:lnRef>
+          <a:fillRef idx="3">
+            <a:schemeClr val="accent1"/>
+          </a:fillRef>
+          <a:effectRef idx="2">
+            <a:schemeClr val="accent1"/>
+          </a:effectRef>
+          <a:fontRef idx="minor">
+            <a:schemeClr val="lt1"/>
+          </a:fontRef>
+        </p:style>
+        <p:txBody>
+          <a:bodyPr rtlCol="0" anchor="ctr"/>
+          <a:lstStyle/>
+          <a:p>
+            <a:pPr algn="ctr"/>
+          </a:p>
+        </p:txBody>
+      </p:sp>
+      <p:sp>
+        <p:nvSpPr>
+          <p:cNvPr id="153" name="Rounded Rectangle 152"/>
+          <p:cNvSpPr/>
+          <p:nvPr/>
+        </p:nvSpPr>
+        <p:spPr>
+          <a:xfrm>
+            <a:off x="8595360" y="3108960"/>
+            <a:ext cx="3291840" cy="1737360"/>
+          </a:xfrm>
+          <a:prstGeom prst="roundRect">
+            <a:avLst/>
+          </a:prstGeom>
+          <a:solidFill>
+            <a:srgbClr val="FEF2F2"/>
+          </a:solidFill>
+          <a:ln w="19050">
+            <a:solidFill>
+              <a:srgbClr val="FCA5A5"/>
+            </a:solidFill>
+          </a:ln>
+        </p:spPr>
+        <p:style>
+          <a:lnRef idx="1">
+            <a:schemeClr val="accent1"/>
+          </a:lnRef>
+          <a:fillRef idx="3">
+            <a:schemeClr val="accent1"/>
+          </a:fillRef>
+          <a:effectRef idx="2">
+            <a:schemeClr val="accent1"/>
+          </a:effectRef>
+          <a:fontRef idx="minor">
+            <a:schemeClr val="lt1"/>
+          </a:fontRef>
+        </p:style>
+        <p:txBody>
+          <a:bodyPr rtlCol="0" anchor="ctr" wrap="square"/>
+          <a:lstStyle/>
+          <a:p>
+            <a:pPr algn="ctr">
+              <a:defRPr sz="1300" b="1">
+                <a:solidFill>
+                  <a:srgbClr val="DC2626"/>
+                </a:solidFill>
+                <a:latin typeface="Calibri"/>
+              </a:defRPr>
+            </a:pPr>
+            <a:r>
+              <a:t>Process 2.0</a:t>
+            </a:r>
+            <a:br/>
+            <a:r>
+              <a:t>ZERO-HALLUCINATION GATE</a:t>
+            </a:r>
+            <a:br/>
+            <a:r>
+              <a:t>(Cross-checks Gaps &amp; Blocks)</a:t>
+            </a:r>
+          </a:p>
+        </p:txBody>
+      </p:sp>
+      <p:sp>
+        <p:nvSpPr>
+          <p:cNvPr id="154" name="Right Arrow 153"/>
+          <p:cNvSpPr/>
+          <p:nvPr/>
+        </p:nvSpPr>
+        <p:spPr>
+          <a:xfrm>
+            <a:off x="11978640" y="3794760"/>
+            <a:ext cx="548640" cy="365760"/>
+          </a:xfrm>
+          <a:prstGeom prst="rightArrow">
+            <a:avLst/>
+          </a:prstGeom>
+          <a:solidFill>
+            <a:srgbClr val="16A34A"/>
+          </a:solidFill>
+          <a:ln>
+            <a:noFill/>
+          </a:ln>
+        </p:spPr>
+        <p:style>
+          <a:lnRef idx="1">
+            <a:schemeClr val="accent1"/>
+          </a:lnRef>
+          <a:fillRef idx="3">
+            <a:schemeClr val="accent1"/>
+          </a:fillRef>
+          <a:effectRef idx="2">
+            <a:schemeClr val="accent1"/>
+          </a:effectRef>
+          <a:fontRef idx="minor">
+            <a:schemeClr val="lt1"/>
+          </a:fontRef>
+        </p:style>
+        <p:txBody>
+          <a:bodyPr rtlCol="0" anchor="ctr"/>
+          <a:lstStyle/>
+          <a:p>
+            <a:pPr algn="ctr"/>
+          </a:p>
+        </p:txBody>
+      </p:sp>
+      <p:sp>
+        <p:nvSpPr>
+          <p:cNvPr id="155" name="Rounded Rectangle 154"/>
+          <p:cNvSpPr/>
+          <p:nvPr/>
+        </p:nvSpPr>
+        <p:spPr>
+          <a:xfrm>
+            <a:off x="12618720" y="3108960"/>
+            <a:ext cx="4114800" cy="1737360"/>
+          </a:xfrm>
+          <a:prstGeom prst="roundRect">
+            <a:avLst/>
+          </a:prstGeom>
+          <a:solidFill>
+            <a:srgbClr val="F0FDF4"/>
+          </a:solidFill>
+          <a:ln w="19050">
+            <a:solidFill>
+              <a:srgbClr val="86EFAC"/>
+            </a:solidFill>
+          </a:ln>
+        </p:spPr>
+        <p:style>
+          <a:lnRef idx="1">
+            <a:schemeClr val="accent1"/>
+          </a:lnRef>
+          <a:fillRef idx="3">
+            <a:schemeClr val="accent1"/>
+          </a:fillRef>
+          <a:effectRef idx="2">
+            <a:schemeClr val="accent1"/>
+          </a:effectRef>
+          <a:fontRef idx="minor">
+            <a:schemeClr val="lt1"/>
+          </a:fontRef>
+        </p:style>
+        <p:txBody>
+          <a:bodyPr rtlCol="0" anchor="ctr" wrap="square"/>
+          <a:lstStyle/>
+          <a:p>
+            <a:pPr algn="ctr">
+              <a:defRPr sz="1300" b="1">
+                <a:solidFill>
+                  <a:srgbClr val="16A34A"/>
+                </a:solidFill>
+                <a:latin typeface="Calibri"/>
+              </a:defRPr>
+            </a:pPr>
+            <a:r>
+              <a:t>Process 5.0</a:t>
+            </a:r>
+            <a:br/>
+            <a:r>
+              <a:t>DELIBERATION &amp; ACTION DISPATCH</a:t>
+            </a:r>
+            <a:br/>
+            <a:r>
+              <a:t>(Approved • PO Created • Ledger Committed)</a:t>
+            </a:r>
+          </a:p>
+        </p:txBody>
+      </p:sp>
+      <p:sp>
+        <p:nvSpPr>
+          <p:cNvPr id="156" name="Down Arrow 155"/>
+          <p:cNvSpPr/>
+          <p:nvPr/>
+        </p:nvSpPr>
+        <p:spPr>
+          <a:xfrm>
+            <a:off x="10058400" y="4937760"/>
+            <a:ext cx="365760" cy="457200"/>
+          </a:xfrm>
+          <a:prstGeom prst="downArrow">
+            <a:avLst/>
+          </a:prstGeom>
+          <a:solidFill>
+            <a:srgbClr val="D97706"/>
+          </a:solidFill>
+          <a:ln>
+            <a:noFill/>
+          </a:ln>
+        </p:spPr>
+        <p:style>
+          <a:lnRef idx="1">
+            <a:schemeClr val="accent1"/>
+          </a:lnRef>
+          <a:fillRef idx="3">
+            <a:schemeClr val="accent1"/>
+          </a:fillRef>
+          <a:effectRef idx="2">
+            <a:schemeClr val="accent1"/>
+          </a:effectRef>
+          <a:fontRef idx="minor">
+            <a:schemeClr val="lt1"/>
+          </a:fontRef>
+        </p:style>
+        <p:txBody>
+          <a:bodyPr rtlCol="0" anchor="ctr"/>
+          <a:lstStyle/>
+          <a:p>
+            <a:pPr algn="ctr"/>
+          </a:p>
+        </p:txBody>
+      </p:sp>
+      <p:sp>
+        <p:nvSpPr>
+          <p:cNvPr id="157" name="Rounded Rectangle 156"/>
+          <p:cNvSpPr/>
+          <p:nvPr/>
+        </p:nvSpPr>
+        <p:spPr>
+          <a:xfrm>
+            <a:off x="7772400" y="5486400"/>
+            <a:ext cx="4937760" cy="1737360"/>
+          </a:xfrm>
+          <a:prstGeom prst="roundRect">
+            <a:avLst/>
+          </a:prstGeom>
+          <a:solidFill>
+            <a:srgbClr val="F0FDFA"/>
+          </a:solidFill>
+          <a:ln w="19050">
+            <a:solidFill>
+              <a:srgbClr val="5EEAD4"/>
+            </a:solidFill>
+          </a:ln>
+        </p:spPr>
+        <p:style>
+          <a:lnRef idx="1">
+            <a:schemeClr val="accent1"/>
+          </a:lnRef>
+          <a:fillRef idx="3">
+            <a:schemeClr val="accent1"/>
+          </a:fillRef>
+          <a:effectRef idx="2">
+            <a:schemeClr val="accent1"/>
+          </a:effectRef>
+          <a:fontRef idx="minor">
+            <a:schemeClr val="lt1"/>
+          </a:fontRef>
+        </p:style>
+        <p:txBody>
+          <a:bodyPr rtlCol="0" anchor="ctr" lIns="228600" tIns="137160" wrap="square"/>
+          <a:lstStyle/>
+          <a:p>
+            <a:pPr algn="ctr">
+              <a:spcAft>
+                <a:spcPts val="200"/>
+              </a:spcAft>
+              <a:defRPr sz="1300" b="1">
+                <a:solidFill>
+                  <a:srgbClr val="0D9488"/>
+                </a:solidFill>
+                <a:latin typeface="Calibri"/>
+              </a:defRPr>
+            </a:pPr>
+            <a:r>
+              <a:t>Process 3.0: AUTONOMOUS SELF-HEALING RETRIEVAL</a:t>
             </a:r>
           </a:p>
           <a:p>
             <a:pPr>
-              <a:spcAft>
-                <a:spcPts val="1000"/>
-              </a:spcAft>
+              <a:defRPr sz="1100">
+                <a:solidFill>
+                  <a:srgbClr val="334155"/>
+                </a:solidFill>
+                <a:latin typeface="Calibri"/>
+              </a:defRPr>
             </a:pPr>
             <a:r>
-              <a:rPr sz="1400" b="1">
-                <a:solidFill>
-                  <a:srgbClr val="0D9488"/>
-                </a:solidFill>
-                <a:latin typeface="Calibri"/>
-              </a:rPr>
-              <a:t>Step 1: Request Intake Arrives: </a:t>
-            </a:r>
-            <a:r>
-              <a:rPr sz="1300">
-                <a:solidFill>
-                  <a:srgbClr val="334155"/>
-                </a:solidFill>
-                <a:latin typeface="Calibri"/>
-              </a:rPr>
-              <a:t>Transaction arrives via intake form, webhook, or email with initial context &amp; attachments.</a:t>
+              <a:t>• D1: Google Drive Vault (Indexed PDFs, SOC2, Appraisals)</a:t>
             </a:r>
           </a:p>
           <a:p>
             <a:pPr>
-              <a:spcAft>
-                <a:spcPts val="1000"/>
-              </a:spcAft>
+              <a:defRPr sz="1100">
+                <a:solidFill>
+                  <a:srgbClr val="334155"/>
+                </a:solidFill>
+                <a:latin typeface="Calibri"/>
+              </a:defRPr>
             </a:pPr>
             <a:r>
-              <a:rPr sz="1400" b="1">
-                <a:solidFill>
-                  <a:srgbClr val="0D9488"/>
-                </a:solidFill>
-                <a:latin typeface="Calibri"/>
-              </a:rPr>
-              <a:t>Step 2: AI Dynamic Evidence Planning: </a:t>
-            </a:r>
-            <a:r>
-              <a:rPr sz="1300">
-                <a:solidFill>
-                  <a:srgbClr val="334155"/>
-                </a:solidFill>
-                <a:latin typeface="Calibri"/>
-              </a:rPr>
-              <a:t>AI reads the request &amp; context, inferring exact required evidence (price, SLAs, SOC2, budget).</a:t>
+              <a:t>• D2: Corporate Mailbox (Gmail / M365 Exchange Threads)</a:t>
             </a:r>
           </a:p>
           <a:p>
             <a:pPr>
-              <a:spcAft>
-                <a:spcPts val="1000"/>
-              </a:spcAft>
+              <a:defRPr sz="1100">
+                <a:solidFill>
+                  <a:srgbClr val="334155"/>
+                </a:solidFill>
+                <a:latin typeface="Calibri"/>
+              </a:defRPr>
             </a:pPr>
             <a:r>
-              <a:rPr sz="1400" b="1">
-                <a:solidFill>
-                  <a:srgbClr val="0D9488"/>
-                </a:solidFill>
-                <a:latin typeface="Calibri"/>
-              </a:rPr>
-              <a:t>Step 3 &amp; 4: Initial Gap Audit &amp; Gatekeeper Block: </a:t>
-            </a:r>
-            <a:r>
-              <a:rPr sz="1300">
-                <a:solidFill>
-                  <a:srgbClr val="334155"/>
-                </a:solidFill>
-                <a:latin typeface="Calibri"/>
-              </a:rPr>
-              <a:t>Engine cross-checks initial dossier against specs. Gaps found (e.g. SOC2, Budget) -&gt; Engine HALTS.</a:t>
+              <a:t>• D3: NetSuite ERP Ledger (Vendor Reliability &amp; Financials)</a:t>
             </a:r>
           </a:p>
           <a:p>
             <a:pPr>
-              <a:spcAft>
-                <a:spcPts val="1000"/>
-              </a:spcAft>
+              <a:defRPr sz="1100">
+                <a:solidFill>
+                  <a:srgbClr val="334155"/>
+                </a:solidFill>
+                <a:latin typeface="Calibri"/>
+              </a:defRPr>
             </a:pPr>
             <a:r>
-              <a:rPr sz="1400" b="1">
-                <a:solidFill>
-                  <a:srgbClr val="0D9488"/>
+              <a:t>• D4: External Registries (D&amp;B, OFAC Sanctions, SEC Edgar)</a:t>
+            </a:r>
+          </a:p>
+        </p:txBody>
+      </p:sp>
+      <p:sp>
+        <p:nvSpPr>
+          <p:cNvPr id="158" name="Left Arrow 157"/>
+          <p:cNvSpPr/>
+          <p:nvPr/>
+        </p:nvSpPr>
+        <p:spPr>
+          <a:xfrm>
+            <a:off x="7132320" y="6217920"/>
+            <a:ext cx="548640" cy="365760"/>
+          </a:xfrm>
+          <a:prstGeom prst="leftArrow">
+            <a:avLst/>
+          </a:prstGeom>
+          <a:solidFill>
+            <a:srgbClr val="D97706"/>
+          </a:solidFill>
+          <a:ln>
+            <a:noFill/>
+          </a:ln>
+        </p:spPr>
+        <p:style>
+          <a:lnRef idx="1">
+            <a:schemeClr val="accent1"/>
+          </a:lnRef>
+          <a:fillRef idx="3">
+            <a:schemeClr val="accent1"/>
+          </a:fillRef>
+          <a:effectRef idx="2">
+            <a:schemeClr val="accent1"/>
+          </a:effectRef>
+          <a:fontRef idx="minor">
+            <a:schemeClr val="lt1"/>
+          </a:fontRef>
+        </p:style>
+        <p:txBody>
+          <a:bodyPr rtlCol="0" anchor="ctr"/>
+          <a:lstStyle/>
+          <a:p>
+            <a:pPr algn="ctr"/>
+          </a:p>
+        </p:txBody>
+      </p:sp>
+      <p:sp>
+        <p:nvSpPr>
+          <p:cNvPr id="159" name="Rounded Rectangle 158"/>
+          <p:cNvSpPr/>
+          <p:nvPr/>
+        </p:nvSpPr>
+        <p:spPr>
+          <a:xfrm>
+            <a:off x="1280160" y="5486400"/>
+            <a:ext cx="5760720" cy="1737360"/>
+          </a:xfrm>
+          <a:prstGeom prst="roundRect">
+            <a:avLst/>
+          </a:prstGeom>
+          <a:solidFill>
+            <a:srgbClr val="FEF3C7"/>
+          </a:solidFill>
+          <a:ln w="19050">
+            <a:solidFill>
+              <a:srgbClr val="FCD34D"/>
+            </a:solidFill>
+          </a:ln>
+        </p:spPr>
+        <p:style>
+          <a:lnRef idx="1">
+            <a:schemeClr val="accent1"/>
+          </a:lnRef>
+          <a:fillRef idx="3">
+            <a:schemeClr val="accent1"/>
+          </a:fillRef>
+          <a:effectRef idx="2">
+            <a:schemeClr val="accent1"/>
+          </a:effectRef>
+          <a:fontRef idx="minor">
+            <a:schemeClr val="lt1"/>
+          </a:fontRef>
+        </p:style>
+        <p:txBody>
+          <a:bodyPr rtlCol="0" anchor="ctr" lIns="274320" tIns="137160" wrap="square"/>
+          <a:lstStyle/>
+          <a:p>
+            <a:pPr algn="ctr">
+              <a:spcAft>
+                <a:spcPts val="300"/>
+              </a:spcAft>
+              <a:defRPr sz="1300" b="1">
+                <a:solidFill>
+                  <a:srgbClr val="D97706"/>
                 </a:solidFill>
                 <a:latin typeface="Calibri"/>
-              </a:rPr>
-              <a:t>Step 5: Autonomous Multi-Source Self-Healing: </a:t>
-            </a:r>
-            <a:r>
-              <a:rPr sz="1300">
-                <a:solidFill>
-                  <a:srgbClr val="334155"/>
-                </a:solidFill>
-                <a:latin typeface="Calibri"/>
-              </a:rPr>
-              <a:t>Engine searches connected silos: Google Drive finds SOC2 cert; NetSuite ERP verifies vendor reliability.</a:t>
+              </a:defRPr>
+            </a:pPr>
+            <a:r>
+              <a:t>Process 4.0: PRECISION HITL MICRO-REQUEST</a:t>
             </a:r>
           </a:p>
           <a:p>
             <a:pPr>
-              <a:spcAft>
-                <a:spcPts val="1000"/>
-              </a:spcAft>
+              <a:defRPr sz="1150">
+                <a:solidFill>
+                  <a:srgbClr val="334155"/>
+                </a:solidFill>
+                <a:latin typeface="Calibri"/>
+              </a:defRPr>
             </a:pPr>
             <a:r>
-              <a:rPr sz="1400" b="1">
-                <a:solidFill>
-                  <a:srgbClr val="0D9488"/>
-                </a:solidFill>
-                <a:latin typeface="Calibri"/>
-              </a:rPr>
-              <a:t>Step 6: Precision Human-in-the-Loop (HITL): </a:t>
-            </a:r>
-            <a:r>
-              <a:rPr sz="1300">
-                <a:solidFill>
-                  <a:srgbClr val="334155"/>
-                </a:solidFill>
-                <a:latin typeface="Calibri"/>
-              </a:rPr>
-              <a:t>Only budget approval remains absent. Dispatches targeted Slack card to VP Finance for 1-click sign-off.</a:t>
+              <a:t>• Identifies EXACT missing item (e.g. Budget Sign-Off from VP Finance)</a:t>
             </a:r>
           </a:p>
           <a:p>
             <a:pPr>
-              <a:spcAft>
-                <a:spcPts val="1000"/>
-              </a:spcAft>
+              <a:defRPr sz="1150">
+                <a:solidFill>
+                  <a:srgbClr val="334155"/>
+                </a:solidFill>
+                <a:latin typeface="Calibri"/>
+              </a:defRPr>
             </a:pPr>
             <a:r>
-              <a:rPr sz="1400" b="1">
-                <a:solidFill>
-                  <a:srgbClr val="0D9488"/>
-                </a:solidFill>
-                <a:latin typeface="Calibri"/>
-              </a:rPr>
-              <a:t>Step 7: Deliberation, Verdict &amp; Execution: </a:t>
-            </a:r>
-            <a:r>
-              <a:rPr sz="1300">
-                <a:solidFill>
-                  <a:srgbClr val="334155"/>
-                </a:solidFill>
-                <a:latin typeface="Calibri"/>
-              </a:rPr>
-              <a:t>Dossier 100% complete! AI issues calibrated verdict (Approved, 97% confidence), issues PO &amp; notifies team.</a:t>
+              <a:t>• Dispatches targeted Slack card with 1-click Approve/Reject button</a:t>
             </a:r>
           </a:p>
           <a:p>
             <a:pPr>
-              <a:spcAft>
-                <a:spcPts val="1000"/>
-              </a:spcAft>
+              <a:defRPr sz="1150">
+                <a:solidFill>
+                  <a:srgbClr val="334155"/>
+                </a:solidFill>
+                <a:latin typeface="Calibri"/>
+              </a:defRPr>
             </a:pPr>
             <a:r>
-              <a:rPr sz="1400" b="1">
-                <a:solidFill>
-                  <a:srgbClr val="0D9488"/>
+              <a:t>• Takes 15 seconds instead of traditional 30-minute review cycles</a:t>
+            </a:r>
+          </a:p>
+        </p:txBody>
+      </p:sp>
+      <p:sp>
+        <p:nvSpPr>
+          <p:cNvPr id="160" name="Rounded Rectangle 159"/>
+          <p:cNvSpPr/>
+          <p:nvPr/>
+        </p:nvSpPr>
+        <p:spPr>
+          <a:xfrm>
+            <a:off x="1280160" y="7498079"/>
+            <a:ext cx="15453359" cy="1463040"/>
+          </a:xfrm>
+          <a:prstGeom prst="roundRect">
+            <a:avLst/>
+          </a:prstGeom>
+          <a:solidFill>
+            <a:srgbClr val="0F172A"/>
+          </a:solidFill>
+          <a:ln>
+            <a:noFill/>
+          </a:ln>
+        </p:spPr>
+        <p:style>
+          <a:lnRef idx="1">
+            <a:schemeClr val="accent1"/>
+          </a:lnRef>
+          <a:fillRef idx="3">
+            <a:schemeClr val="accent1"/>
+          </a:fillRef>
+          <a:effectRef idx="2">
+            <a:schemeClr val="accent1"/>
+          </a:effectRef>
+          <a:fontRef idx="minor">
+            <a:schemeClr val="lt1"/>
+          </a:fontRef>
+        </p:style>
+        <p:txBody>
+          <a:bodyPr rtlCol="0" anchor="ctr" lIns="365760" rIns="365760"/>
+          <a:lstStyle/>
+          <a:p>
+            <a:pPr algn="ctr">
+              <a:spcAft>
+                <a:spcPts val="200"/>
+              </a:spcAft>
+              <a:defRPr sz="1400" b="1">
+                <a:solidFill>
+                  <a:srgbClr val="5DE0E6"/>
                 </a:solidFill>
                 <a:latin typeface="Calibri"/>
-              </a:rPr>
-              <a:t>Step 8: Continuous Meta-Learning &amp; Process Mining: </a:t>
-            </a:r>
-            <a:r>
-              <a:rPr sz="1300">
-                <a:solidFill>
-                  <a:srgbClr val="334155"/>
+              </a:defRPr>
+            </a:pPr>
+            <a:r>
+              <a:t>Process 6.0: TELEMETRY MINING &amp; CONTINUOUS PROCESS OPTIMIZATION</a:t>
+            </a:r>
+          </a:p>
+          <a:p>
+            <a:pPr>
+              <a:defRPr sz="1200">
+                <a:solidFill>
+                  <a:srgbClr val="FFFFFF"/>
                 </a:solidFill>
                 <a:latin typeface="Calibri"/>
-              </a:rPr>
-              <a:t>Engine analyzes telemetry across decisions; suggests adding budget check to intake form to eliminate future blocks.</a:t>
+              </a:defRPr>
+            </a:pPr>
+            <a:r>
+              <a:t>Every blocked gate, retrieved document, and human micro-interaction is logged. Telemetry detects organizational patterns (e.g. '70% of delays are missing budget sign-off') and proposes automatic intake form redesign to prevent future blocks.</a:t>
             </a:r>
           </a:p>
         </p:txBody>
@@ -15029,7 +16712,7 @@
         <p:spPr>
           <a:xfrm>
             <a:off x="1024128" y="2331720"/>
-            <a:ext cx="16239744" cy="640080"/>
+            <a:ext cx="16239744" cy="594360"/>
           </a:xfrm>
           <a:prstGeom prst="roundRect">
             <a:avLst/>
@@ -15069,7 +16752,7 @@
                 </a:solidFill>
                 <a:latin typeface="Calibri"/>
               </a:rPr>
-              <a:t>🌐 LIVE CLOUD DEMONSTRATION: </a:t>
+              <a:t>🌐 LIVE CLOUD APPLICATION: </a:t>
             </a:r>
             <a:r>
               <a:rPr sz="1400" b="1">
@@ -15078,7 +16761,7 @@
                 </a:solidFill>
                 <a:latin typeface="Calibri"/>
               </a:rPr>
-              <a:t>https://static-outstanding-palm-clarke.trycloudflare.com  (Fast &lt;50ms, 8 Enterprise Domains)</a:t>
+              <a:t>https://static-outstanding-palm-clarke.trycloudflare.com  [⚡ Fast &lt;50ms | 8 Domains | Zero Hallucination]</a:t>
             </a:r>
           </a:p>
         </p:txBody>
@@ -15091,7 +16774,7 @@
         </p:nvSpPr>
         <p:spPr>
           <a:xfrm>
-            <a:off x="1024128" y="3108960"/>
+            <a:off x="1024128" y="3063240"/>
             <a:ext cx="16239744" cy="6309360"/>
           </a:xfrm>
           <a:prstGeom prst="roundRect">
@@ -15121,172 +16804,461 @@
           </a:fontRef>
         </p:style>
         <p:txBody>
-          <a:bodyPr rtlCol="0" anchor="t" lIns="365760" rIns="365760" tIns="274320" wrap="square"/>
+          <a:bodyPr rtlCol="0" anchor="ctr"/>
+          <a:lstStyle/>
+          <a:p>
+            <a:pPr algn="ctr"/>
+          </a:p>
+        </p:txBody>
+      </p:sp>
+      <p:sp>
+        <p:nvSpPr>
+          <p:cNvPr id="157" name="Rounded Rectangle 156"/>
+          <p:cNvSpPr/>
+          <p:nvPr/>
+        </p:nvSpPr>
+        <p:spPr>
+          <a:xfrm>
+            <a:off x="1024128" y="3063240"/>
+            <a:ext cx="16239744" cy="502920"/>
+          </a:xfrm>
+          <a:prstGeom prst="roundRect">
+            <a:avLst/>
+          </a:prstGeom>
+          <a:solidFill>
+            <a:srgbClr val="0F172A"/>
+          </a:solidFill>
+          <a:ln>
+            <a:noFill/>
+          </a:ln>
+        </p:spPr>
+        <p:style>
+          <a:lnRef idx="1">
+            <a:schemeClr val="accent1"/>
+          </a:lnRef>
+          <a:fillRef idx="3">
+            <a:schemeClr val="accent1"/>
+          </a:fillRef>
+          <a:effectRef idx="2">
+            <a:schemeClr val="accent1"/>
+          </a:effectRef>
+          <a:fontRef idx="minor">
+            <a:schemeClr val="lt1"/>
+          </a:fontRef>
+        </p:style>
+        <p:txBody>
+          <a:bodyPr rtlCol="0" anchor="ctr" lIns="365760"/>
           <a:lstStyle/>
           <a:p>
             <a:pPr algn="ctr">
-              <a:spcAft>
-                <a:spcPts val="800"/>
-              </a:spcAft>
-              <a:defRPr sz="1700" b="1">
-                <a:solidFill>
-                  <a:srgbClr val="0F172A"/>
+              <a:defRPr sz="1200">
+                <a:solidFill>
+                  <a:srgbClr val="E2E8F0"/>
                 </a:solidFill>
                 <a:latin typeface="Calibri"/>
               </a:defRPr>
             </a:pPr>
             <a:r>
-              <a:t>DECISION COMPLETENESS ENGINE — VISUAL DECISION STUDIO UI</a:t>
+              <a:t>🔴 🟡 🟢   https://static-outstanding-palm-clarke.trycloudflare.com  —  Decision Completeness Engine Visual Studio</a:t>
+            </a:r>
+          </a:p>
+        </p:txBody>
+      </p:sp>
+      <p:sp>
+        <p:nvSpPr>
+          <p:cNvPr id="158" name="Rounded Rectangle 157"/>
+          <p:cNvSpPr/>
+          <p:nvPr/>
+        </p:nvSpPr>
+        <p:spPr>
+          <a:xfrm>
+            <a:off x="1188720" y="3703320"/>
+            <a:ext cx="15910559" cy="685800"/>
+          </a:xfrm>
+          <a:prstGeom prst="roundRect">
+            <a:avLst/>
+          </a:prstGeom>
+          <a:solidFill>
+            <a:srgbClr val="F8FAFC"/>
+          </a:solidFill>
+          <a:ln w="19050">
+            <a:solidFill>
+              <a:srgbClr val="CBD5E1"/>
+            </a:solidFill>
+          </a:ln>
+        </p:spPr>
+        <p:style>
+          <a:lnRef idx="1">
+            <a:schemeClr val="accent1"/>
+          </a:lnRef>
+          <a:fillRef idx="3">
+            <a:schemeClr val="accent1"/>
+          </a:fillRef>
+          <a:effectRef idx="2">
+            <a:schemeClr val="accent1"/>
+          </a:effectRef>
+          <a:fontRef idx="minor">
+            <a:schemeClr val="lt1"/>
+          </a:fontRef>
+        </p:style>
+        <p:txBody>
+          <a:bodyPr rtlCol="0" anchor="ctr" wrap="square"/>
+          <a:lstStyle/>
+          <a:p>
+            <a:pPr algn="ctr">
+              <a:defRPr sz="1250" b="1">
+                <a:solidFill>
+                  <a:srgbClr val="4F46E5"/>
+                </a:solidFill>
+                <a:latin typeface="Calibri"/>
+              </a:defRPr>
+            </a:pPr>
+            <a:r>
+              <a:t>[01 Intake ✓]  ➜  [02 Plan ✓]  ➜  [03 Audit ✓]  ➜  [04 Gate Block ⛔]  ➜  [05 Self-Heal ✨]  ➜  [06 HITL 👤]  ➜  [07 Verdict 🎯]  ➜  [08 Learn 📊]</a:t>
+            </a:r>
+          </a:p>
+        </p:txBody>
+      </p:sp>
+      <p:sp>
+        <p:nvSpPr>
+          <p:cNvPr id="159" name="Rounded Rectangle 158"/>
+          <p:cNvSpPr/>
+          <p:nvPr/>
+        </p:nvSpPr>
+        <p:spPr>
+          <a:xfrm>
+            <a:off x="1188720" y="4526280"/>
+            <a:ext cx="7772400" cy="4663440"/>
+          </a:xfrm>
+          <a:prstGeom prst="roundRect">
+            <a:avLst/>
+          </a:prstGeom>
+          <a:solidFill>
+            <a:srgbClr val="FFFFFF"/>
+          </a:solidFill>
+          <a:ln w="19050">
+            <a:solidFill>
+              <a:srgbClr val="CBD5E1"/>
+            </a:solidFill>
+          </a:ln>
+        </p:spPr>
+        <p:style>
+          <a:lnRef idx="1">
+            <a:schemeClr val="accent1"/>
+          </a:lnRef>
+          <a:fillRef idx="3">
+            <a:schemeClr val="accent1"/>
+          </a:fillRef>
+          <a:effectRef idx="2">
+            <a:schemeClr val="accent1"/>
+          </a:effectRef>
+          <a:fontRef idx="minor">
+            <a:schemeClr val="lt1"/>
+          </a:fontRef>
+        </p:style>
+        <p:txBody>
+          <a:bodyPr rtlCol="0" anchor="ctr" lIns="274320" rIns="274320" tIns="182880" wrap="square"/>
+          <a:lstStyle/>
+          <a:p>
+            <a:pPr algn="ctr">
+              <a:spcAft>
+                <a:spcPts val="800"/>
+              </a:spcAft>
+              <a:defRPr sz="1300" b="1">
+                <a:solidFill>
+                  <a:srgbClr val="0F172A"/>
+                </a:solidFill>
+                <a:latin typeface="Calibri"/>
+              </a:defRPr>
+            </a:pPr>
+            <a:r>
+              <a:t>EVIDENCE SPECIFICATION MATRIX (LIVE DOSSIER)</a:t>
             </a:r>
           </a:p>
           <a:p>
             <a:pPr>
               <a:spcAft>
-                <a:spcPts val="800"/>
+                <a:spcPts val="600"/>
               </a:spcAft>
             </a:pPr>
             <a:r>
-              <a:rPr sz="1300" b="1">
-                <a:solidFill>
-                  <a:srgbClr val="0D9488"/>
+              <a:rPr sz="1150" b="1">
+                <a:solidFill>
+                  <a:srgbClr val="1E293B"/>
                 </a:solidFill>
                 <a:latin typeface="Calibri"/>
               </a:rPr>
-              <a:t>⚡ Real-Time 8-Step Pipeline Stepper: </a:t>
-            </a:r>
-            <a:r>
-              <a:rPr sz="1250">
-                <a:solidFill>
-                  <a:srgbClr val="334155"/>
+              <a:t>Competitive Price Benchmark
+</a:t>
+            </a:r>
+            <a:r>
+              <a:rPr sz="1050" b="1">
+                <a:solidFill>
+                  <a:srgbClr val="16A34A"/>
                 </a:solidFill>
                 <a:latin typeface="Calibri"/>
               </a:rPr>
-              <a:t>Animated visual transitions from [01 Intake] through [04 Gatekeeper Block] to [07 Final Verdict] and [08 Meta-Learning].</a:t>
+              <a:t>  [VERIFIED (95%)] — Direct vendor quotation comparison</a:t>
             </a:r>
           </a:p>
           <a:p>
             <a:pPr>
               <a:spcAft>
-                <a:spcPts val="800"/>
+                <a:spcPts val="600"/>
               </a:spcAft>
             </a:pPr>
             <a:r>
-              <a:rPr sz="1300" b="1">
-                <a:solidFill>
-                  <a:srgbClr val="0D9488"/>
+              <a:rPr sz="1150" b="1">
+                <a:solidFill>
+                  <a:srgbClr val="1E293B"/>
                 </a:solidFill>
                 <a:latin typeface="Calibri"/>
               </a:rPr>
-              <a:t>🎛️ Dual-Speed Execution Controls: </a:t>
-            </a:r>
-            <a:r>
-              <a:rPr sz="1250">
-                <a:solidFill>
-                  <a:srgbClr val="334155"/>
+              <a:t>Delivery Timeline SLA Commitment
+</a:t>
+            </a:r>
+            <a:r>
+              <a:rPr sz="1050" b="1">
+                <a:solidFill>
+                  <a:srgbClr val="16A34A"/>
                 </a:solidFill>
                 <a:latin typeface="Calibri"/>
               </a:rPr>
-              <a:t>Switch between ⚡ Turbo Mode (Instant &lt; 50ms) for high-throughput evaluation, and 🏎️ Fast Mode (Animated 350ms) for visual demonstrations.</a:t>
+              <a:t>  [VERIFIED (92%)] — 14-day turnaround SLA verified</a:t>
             </a:r>
           </a:p>
           <a:p>
             <a:pPr>
               <a:spcAft>
-                <a:spcPts val="800"/>
+                <a:spcPts val="600"/>
               </a:spcAft>
             </a:pPr>
             <a:r>
-              <a:rPr sz="1300" b="1">
-                <a:solidFill>
-                  <a:srgbClr val="0D9488"/>
+              <a:rPr sz="1150" b="1">
+                <a:solidFill>
+                  <a:srgbClr val="1E293B"/>
                 </a:solidFill>
                 <a:latin typeface="Calibri"/>
               </a:rPr>
-              <a:t>📋 Live Evidence Specification Matrix: </a:t>
-            </a:r>
-            <a:r>
-              <a:rPr sz="1250">
-                <a:solidFill>
-                  <a:srgbClr val="334155"/>
+              <a:t>SOC2 Type II Security Certificate
+</a:t>
+            </a:r>
+            <a:r>
+              <a:rPr sz="1050" b="1">
+                <a:solidFill>
+                  <a:srgbClr val="0D9488"/>
                 </a:solidFill>
                 <a:latin typeface="Calibri"/>
               </a:rPr>
-              <a:t>Color-coded status badges: [VERIFIED], [✨ SELF-HEALED from Drive/ERP], [👤 HITL APPROVED], and [❌ MISSING GAP] with source citations &amp; confidence meters.</a:t>
+              <a:t>  [✨ SELF-HEALED] — Retrieved from Corporate Drive Vault</a:t>
             </a:r>
           </a:p>
           <a:p>
             <a:pPr>
               <a:spcAft>
-                <a:spcPts val="800"/>
+                <a:spcPts val="600"/>
               </a:spcAft>
             </a:pPr>
             <a:r>
-              <a:rPr sz="1300" b="1">
-                <a:solidFill>
-                  <a:srgbClr val="0D9488"/>
+              <a:rPr sz="1150" b="1">
+                <a:solidFill>
+                  <a:srgbClr val="1E293B"/>
                 </a:solidFill>
                 <a:latin typeface="Calibri"/>
               </a:rPr>
-              <a:t>🛡️ Interactive Zero-Hallucination Gatekeeper: </a:t>
-            </a:r>
-            <a:r>
-              <a:rPr sz="1250">
-                <a:solidFill>
-                  <a:srgbClr val="334155"/>
+              <a:t>Past Delivery Track Record (98%)
+</a:t>
+            </a:r>
+            <a:r>
+              <a:rPr sz="1050" b="1">
+                <a:solidFill>
+                  <a:srgbClr val="0D9488"/>
                 </a:solidFill>
                 <a:latin typeface="Calibri"/>
               </a:rPr>
-              <a:t>Visual security block card prevents LLM guessing when evidence threshold is unsatisfied; details exact missing delta.</a:t>
+              <a:t>  [✨ SELF-HEALED] — Retrieved from NetSuite ERP Ledger</a:t>
             </a:r>
           </a:p>
           <a:p>
             <a:pPr>
               <a:spcAft>
-                <a:spcPts val="800"/>
+                <a:spcPts val="600"/>
               </a:spcAft>
             </a:pPr>
             <a:r>
-              <a:rPr sz="1300" b="1">
-                <a:solidFill>
-                  <a:srgbClr val="0D9488"/>
+              <a:rPr sz="1150" b="1">
+                <a:solidFill>
+                  <a:srgbClr val="1E293B"/>
                 </a:solidFill>
                 <a:latin typeface="Calibri"/>
               </a:rPr>
-              <a:t>👤 Precision HITL Micro-Ask Simulator: </a:t>
-            </a:r>
-            <a:r>
-              <a:rPr sz="1250">
-                <a:solidFill>
-                  <a:srgbClr val="334155"/>
+              <a:t>Budget Sign-Off (VP Finance)
+</a:t>
+            </a:r>
+            <a:r>
+              <a:rPr sz="1050" b="1">
+                <a:solidFill>
+                  <a:srgbClr val="D97706"/>
                 </a:solidFill>
                 <a:latin typeface="Calibri"/>
               </a:rPr>
-              <a:t>Targeted 1-click interactive approval card simulating Slack/Email push notifications (testable live in the browser).</a:t>
+              <a:t>  [👤 HITL SIGNED] — Approved in 15s via targeted Slack card</a:t>
+            </a:r>
+          </a:p>
+        </p:txBody>
+      </p:sp>
+      <p:sp>
+        <p:nvSpPr>
+          <p:cNvPr id="160" name="Rounded Rectangle 159"/>
+          <p:cNvSpPr/>
+          <p:nvPr/>
+        </p:nvSpPr>
+        <p:spPr>
+          <a:xfrm>
+            <a:off x="9235440" y="4526280"/>
+            <a:ext cx="7863840" cy="4663440"/>
+          </a:xfrm>
+          <a:prstGeom prst="roundRect">
+            <a:avLst/>
+          </a:prstGeom>
+          <a:solidFill>
+            <a:srgbClr val="FFFFFF"/>
+          </a:solidFill>
+          <a:ln w="19050">
+            <a:solidFill>
+              <a:srgbClr val="86EFAC"/>
+            </a:solidFill>
+          </a:ln>
+        </p:spPr>
+        <p:style>
+          <a:lnRef idx="1">
+            <a:schemeClr val="accent1"/>
+          </a:lnRef>
+          <a:fillRef idx="3">
+            <a:schemeClr val="accent1"/>
+          </a:fillRef>
+          <a:effectRef idx="2">
+            <a:schemeClr val="accent1"/>
+          </a:effectRef>
+          <a:fontRef idx="minor">
+            <a:schemeClr val="lt1"/>
+          </a:fontRef>
+        </p:style>
+        <p:txBody>
+          <a:bodyPr rtlCol="0" anchor="ctr" lIns="274320" rIns="274320" tIns="182880" wrap="square"/>
+          <a:lstStyle/>
+          <a:p>
+            <a:pPr algn="ctr">
+              <a:spcAft>
+                <a:spcPts val="600"/>
+              </a:spcAft>
+              <a:defRPr sz="1300" b="1">
+                <a:solidFill>
+                  <a:srgbClr val="16A34A"/>
+                </a:solidFill>
+                <a:latin typeface="Calibri"/>
+              </a:defRPr>
+            </a:pPr>
+            <a:r>
+              <a:t>GATEKEEPER VERDICT &amp; DOWNSTREAM ACTIONS</a:t>
             </a:r>
           </a:p>
           <a:p>
             <a:pPr>
               <a:spcAft>
+                <a:spcPts val="1000"/>
+              </a:spcAft>
+              <a:defRPr sz="1200" b="1">
+                <a:solidFill>
+                  <a:srgbClr val="0F172A"/>
+                </a:solidFill>
+                <a:latin typeface="Calibri"/>
+              </a:defRPr>
+            </a:pPr>
+            <a:r>
+              <a:t>Completeness Score: 100% (All Critical Requirements Met)</a:t>
+            </a:r>
+            <a:br/>
+            <a:r>
+              <a:t>Verdict: APPROVED  |  Confidence Score: 97%</a:t>
+            </a:r>
+          </a:p>
+          <a:p>
+            <a:pPr>
+              <a:spcAft>
                 <a:spcPts val="800"/>
               </a:spcAft>
             </a:pPr>
             <a:r>
-              <a:rPr sz="1300" b="1">
-                <a:solidFill>
-                  <a:srgbClr val="0D9488"/>
+              <a:rPr sz="1150" b="1">
+                <a:solidFill>
+                  <a:srgbClr val="4F46E5"/>
                 </a:solidFill>
                 <a:latin typeface="Calibri"/>
               </a:rPr>
-              <a:t>📊 Continuous Process Mining Dashboard: </a:t>
-            </a:r>
-            <a:r>
-              <a:rPr sz="1250">
+              <a:t>⚡ Action 1: ERP Purchase Order Dispatched
+</a:t>
+            </a:r>
+            <a:r>
+              <a:rPr sz="1050">
                 <a:solidFill>
                   <a:srgbClr val="334155"/>
                 </a:solidFill>
                 <a:latin typeface="Calibri"/>
               </a:rPr>
-              <a:t>Live telemetric charts computing Gatekeeper Block Rate (62%), Self-Healing Rate (88%), and automated intake form redesign suggestions.</a:t>
+              <a:t>  PO #PO-88421 committed to NetSuite with line-item schedule.</a:t>
+            </a:r>
+          </a:p>
+          <a:p>
+            <a:pPr>
+              <a:spcAft>
+                <a:spcPts val="800"/>
+              </a:spcAft>
+            </a:pPr>
+            <a:r>
+              <a:rPr sz="1150" b="1">
+                <a:solidFill>
+                  <a:srgbClr val="4F46E5"/>
+                </a:solidFill>
+                <a:latin typeface="Calibri"/>
+              </a:rPr>
+              <a:t>💬 Action 2: Precision Slack Alert Sent
+</a:t>
+            </a:r>
+            <a:r>
+              <a:rPr sz="1050">
+                <a:solidFill>
+                  <a:srgbClr val="334155"/>
+                </a:solidFill>
+                <a:latin typeface="Calibri"/>
+              </a:rPr>
+              <a:t>  Requester and procurement channel notified in real-time.</a:t>
+            </a:r>
+          </a:p>
+          <a:p>
+            <a:pPr>
+              <a:spcAft>
+                <a:spcPts val="800"/>
+              </a:spcAft>
+            </a:pPr>
+            <a:r>
+              <a:rPr sz="1150" b="1">
+                <a:solidFill>
+                  <a:srgbClr val="4F46E5"/>
+                </a:solidFill>
+                <a:latin typeface="Calibri"/>
+              </a:rPr>
+              <a:t>🔒 Action 3: Cryptographic Audit Ledger
+</a:t>
+            </a:r>
+            <a:r>
+              <a:rPr sz="1050">
+                <a:solidFill>
+                  <a:srgbClr val="334155"/>
+                </a:solidFill>
+                <a:latin typeface="Calibri"/>
+              </a:rPr>
+              <a:t>  SHA-256 chain-of-custody hash committed: `0x7f8a9...b34c`.</a:t>
             </a:r>
           </a:p>
         </p:txBody>
@@ -15482,7 +17454,7 @@
           </a:solidFill>
           <a:ln w="19050">
             <a:solidFill>
-              <a:srgbClr val="CBD5E1"/>
+              <a:srgbClr val="C7D2FE"/>
             </a:solidFill>
           </a:ln>
         </p:spPr>
@@ -15501,22 +17473,22 @@
           </a:fontRef>
         </p:style>
         <p:txBody>
-          <a:bodyPr rtlCol="0" anchor="t" lIns="274320" rIns="274320" tIns="274320" wrap="square"/>
+          <a:bodyPr rtlCol="0" anchor="ctr" lIns="274320" rIns="274320" tIns="274320" wrap="square"/>
           <a:lstStyle/>
           <a:p>
             <a:pPr algn="ctr">
               <a:spcAft>
                 <a:spcPts val="800"/>
               </a:spcAft>
-              <a:defRPr sz="1600" b="1">
-                <a:solidFill>
-                  <a:srgbClr val="0F172A"/>
+              <a:defRPr sz="1400" b="1">
+                <a:solidFill>
+                  <a:srgbClr val="4F46E5"/>
                 </a:solidFill>
                 <a:latin typeface="Calibri"/>
               </a:defRPr>
             </a:pPr>
             <a:r>
-              <a:t>8 ENTERPRISE DOMAINS</a:t>
+              <a:t>8 ENTERPRISE DOMAINS (READY-TO-DEMO)</a:t>
             </a:r>
           </a:p>
           <a:p>
@@ -15526,22 +17498,22 @@
               </a:spcAft>
             </a:pPr>
             <a:r>
-              <a:rPr sz="1150" b="1">
-                <a:solidFill>
-                  <a:srgbClr val="4F46E5"/>
+              <a:rPr sz="1100" b="1">
+                <a:solidFill>
+                  <a:srgbClr val="0F172A"/>
                 </a:solidFill>
                 <a:latin typeface="Calibri"/>
               </a:rPr>
               <a:t>1. Hardware Procurement: </a:t>
             </a:r>
             <a:r>
-              <a:rPr sz="1100">
+              <a:rPr sz="1050">
                 <a:solidFill>
                   <a:srgbClr val="334155"/>
                 </a:solidFill>
                 <a:latin typeface="Calibri"/>
               </a:rPr>
-              <a:t>$85k Laptops • Recovers SOC2 from Drive; asks VP Finance.</a:t>
+              <a:t>$85k Laptops • Recovers SOC2; asks VP.</a:t>
             </a:r>
           </a:p>
           <a:p>
@@ -15551,22 +17523,22 @@
               </a:spcAft>
             </a:pPr>
             <a:r>
-              <a:rPr sz="1150" b="1">
-                <a:solidFill>
-                  <a:srgbClr val="4F46E5"/>
+              <a:rPr sz="1100" b="1">
+                <a:solidFill>
+                  <a:srgbClr val="0F172A"/>
                 </a:solidFill>
                 <a:latin typeface="Calibri"/>
               </a:rPr>
-              <a:t>2. FinTech Lending: </a:t>
-            </a:r>
-            <a:r>
-              <a:rPr sz="1100">
+              <a:t>2. Commercial Lending: </a:t>
+            </a:r>
+            <a:r>
+              <a:rPr sz="1050">
                 <a:solidFill>
                   <a:srgbClr val="334155"/>
                 </a:solidFill>
                 <a:latin typeface="Calibri"/>
               </a:rPr>
-              <a:t>$250k Apex Revolving • Recovers Form 1120-S &amp; 12M bank records.</a:t>
+              <a:t>$250k Apex Revolving • Recovers Form 1120-S.</a:t>
             </a:r>
           </a:p>
           <a:p>
@@ -15576,22 +17548,22 @@
               </a:spcAft>
             </a:pPr>
             <a:r>
-              <a:rPr sz="1150" b="1">
-                <a:solidFill>
-                  <a:srgbClr val="4F46E5"/>
+              <a:rPr sz="1100" b="1">
+                <a:solidFill>
+                  <a:srgbClr val="0F172A"/>
                 </a:solidFill>
                 <a:latin typeface="Calibri"/>
               </a:rPr>
               <a:t>3. Executive Hiring: </a:t>
             </a:r>
             <a:r>
-              <a:rPr sz="1100">
+              <a:rPr sz="1050">
                 <a:solidFill>
                   <a:srgbClr val="334155"/>
                 </a:solidFill>
                 <a:latin typeface="Calibri"/>
               </a:rPr>
-              <a:t>VP Eng Offer • Recovers Sterling background check &amp; reference.</a:t>
+              <a:t>VP Eng Offer • Recovers Sterling &amp; references.</a:t>
             </a:r>
           </a:p>
           <a:p>
@@ -15601,22 +17573,22 @@
               </a:spcAft>
             </a:pPr>
             <a:r>
-              <a:rPr sz="1150" b="1">
-                <a:solidFill>
-                  <a:srgbClr val="4F46E5"/>
+              <a:rPr sz="1100" b="1">
+                <a:solidFill>
+                  <a:srgbClr val="0F172A"/>
                 </a:solidFill>
                 <a:latin typeface="Calibri"/>
               </a:rPr>
               <a:t>4. Healthcare Claims: </a:t>
             </a:r>
             <a:r>
-              <a:rPr sz="1100">
+              <a:rPr sz="1050">
                 <a:solidFill>
                   <a:srgbClr val="334155"/>
                 </a:solidFill>
                 <a:latin typeface="Calibri"/>
               </a:rPr>
-              <a:t>$42k Knee Surgery • Recovers surgical op notes &amp; prior auth.</a:t>
+              <a:t>$42k Knee Surgery • Recovers op notes &amp; auth.</a:t>
             </a:r>
           </a:p>
           <a:p>
@@ -15626,22 +17598,22 @@
               </a:spcAft>
             </a:pPr>
             <a:r>
-              <a:rPr sz="1150" b="1">
-                <a:solidFill>
-                  <a:srgbClr val="4F46E5"/>
+              <a:rPr sz="1100" b="1">
+                <a:solidFill>
+                  <a:srgbClr val="0F172A"/>
                 </a:solidFill>
                 <a:latin typeface="Calibri"/>
               </a:rPr>
               <a:t>5. Corporate Expense: </a:t>
             </a:r>
             <a:r>
-              <a:rPr sz="1100">
+              <a:rPr sz="1050">
                 <a:solidFill>
                   <a:srgbClr val="334155"/>
                 </a:solidFill>
                 <a:latin typeface="Calibri"/>
               </a:rPr>
-              <a:t>$14.2k Zurich Dinner • Recovers itemized VAT folio; asks VP.</a:t>
+              <a:t>$14.2k Zurich Dinner • Recovers itemized folio.</a:t>
             </a:r>
           </a:p>
           <a:p>
@@ -15651,22 +17623,22 @@
               </a:spcAft>
             </a:pPr>
             <a:r>
-              <a:rPr sz="1150" b="1">
-                <a:solidFill>
-                  <a:srgbClr val="4F46E5"/>
+              <a:rPr sz="1100" b="1">
+                <a:solidFill>
+                  <a:srgbClr val="0F172A"/>
                 </a:solidFill>
                 <a:latin typeface="Calibri"/>
               </a:rPr>
-              <a:t>6. Legal &amp; SaaS Contract: </a:t>
-            </a:r>
-            <a:r>
-              <a:rPr sz="1100">
+              <a:t>6. Legal SaaS Contract: </a:t>
+            </a:r>
+            <a:r>
+              <a:rPr sz="1050">
                 <a:solidFill>
                   <a:srgbClr val="334155"/>
                 </a:solidFill>
                 <a:latin typeface="Calibri"/>
               </a:rPr>
-              <a:t>VectorFlow AI ($120k/yr) • Recovers executed DPA &amp; covenants.</a:t>
+              <a:t>VectorFlow AI • Recovers DPA &amp; covenants.</a:t>
             </a:r>
           </a:p>
           <a:p>
@@ -15676,22 +17648,22 @@
               </a:spcAft>
             </a:pPr>
             <a:r>
-              <a:rPr sz="1150" b="1">
-                <a:solidFill>
-                  <a:srgbClr val="4F46E5"/>
+              <a:rPr sz="1100" b="1">
+                <a:solidFill>
+                  <a:srgbClr val="0F172A"/>
                 </a:solidFill>
                 <a:latin typeface="Calibri"/>
               </a:rPr>
               <a:t>7. Cloud Firewall Exemption: </a:t>
             </a:r>
             <a:r>
-              <a:rPr sz="1100">
+              <a:rPr sz="1050">
                 <a:solidFill>
                   <a:srgbClr val="334155"/>
                 </a:solidFill>
                 <a:latin typeface="Calibri"/>
               </a:rPr>
-              <a:t>Port 9443 Ingress • Discovers partner mTLS cert &amp; 48h TTL.</a:t>
+              <a:t>Port 9443 Ingress • Recovers partner mTLS cert.</a:t>
             </a:r>
           </a:p>
           <a:p>
@@ -15701,22 +17673,22 @@
               </a:spcAft>
             </a:pPr>
             <a:r>
-              <a:rPr sz="1150" b="1">
-                <a:solidFill>
-                  <a:srgbClr val="4F46E5"/>
+              <a:rPr sz="1100" b="1">
+                <a:solidFill>
+                  <a:srgbClr val="0F172A"/>
                 </a:solidFill>
                 <a:latin typeface="Calibri"/>
               </a:rPr>
-              <a:t>8. Jumbo Mortgage Loan: </a:t>
-            </a:r>
-            <a:r>
-              <a:rPr sz="1100">
+              <a:t>8. Jumbo Real Estate Mortgage: </a:t>
+            </a:r>
+            <a:r>
+              <a:rPr sz="1050">
                 <a:solidFill>
                   <a:srgbClr val="334155"/>
                 </a:solidFill>
                 <a:latin typeface="Calibri"/>
               </a:rPr>
-              <a:t>$850k Loan • Recovers appraisal ($1.15M, 73.9% LTV) &amp; W-2s.</a:t>
+              <a:t>$850k Loan • Recovers $1.15M appraisal &amp; W-2s.</a:t>
             </a:r>
           </a:p>
         </p:txBody>
@@ -15740,7 +17712,7 @@
           </a:solidFill>
           <a:ln w="19050">
             <a:solidFill>
-              <a:srgbClr val="CBD5E1"/>
+              <a:srgbClr val="5EEAD4"/>
             </a:solidFill>
           </a:ln>
         </p:spPr>
@@ -15759,14 +17731,14 @@
           </a:fontRef>
         </p:style>
         <p:txBody>
-          <a:bodyPr rtlCol="0" anchor="t" lIns="274320" rIns="274320" tIns="274320" wrap="square"/>
+          <a:bodyPr rtlCol="0" anchor="ctr" lIns="274320" rIns="274320" tIns="274320" wrap="square"/>
           <a:lstStyle/>
           <a:p>
             <a:pPr algn="ctr">
               <a:spcAft>
                 <a:spcPts val="800"/>
               </a:spcAft>
-              <a:defRPr sz="1600" b="1">
+              <a:defRPr sz="1400" b="1">
                 <a:solidFill>
                   <a:srgbClr val="0D9488"/>
                 </a:solidFill>
@@ -15774,135 +17746,111 @@
               </a:defRPr>
             </a:pPr>
             <a:r>
-              <a:t>QUANTIFIABLE ROI</a:t>
+              <a:t>QUANTIFIABLE BUSINESS VALUE</a:t>
             </a:r>
           </a:p>
           <a:p>
             <a:pPr>
               <a:spcAft>
-                <a:spcPts val="200"/>
+                <a:spcPts val="1000"/>
               </a:spcAft>
             </a:pPr>
             <a:r>
-              <a:rPr sz="1300" b="1">
-                <a:solidFill>
-                  <a:srgbClr val="1E293B"/>
+              <a:rPr sz="1400" b="1">
+                <a:solidFill>
+                  <a:srgbClr val="0D9488"/>
                 </a:solidFill>
                 <a:latin typeface="Calibri"/>
               </a:rPr>
-              <a:t>⚡ 90% Turnaround Reduction</a:t>
+              <a:t>90% Turnaround Reduction
+</a:t>
+            </a:r>
+            <a:r>
+              <a:rPr sz="1100">
+                <a:solidFill>
+                  <a:srgbClr val="334155"/>
+                </a:solidFill>
+                <a:latin typeface="Calibri"/>
+              </a:rPr>
+              <a:t>Drops average approval cycles from 2.5 days down to seconds.</a:t>
             </a:r>
           </a:p>
           <a:p>
             <a:pPr>
               <a:spcAft>
-                <a:spcPts val="1200"/>
-              </a:spcAft>
-              <a:defRPr sz="1200">
+                <a:spcPts val="1000"/>
+              </a:spcAft>
+            </a:pPr>
+            <a:r>
+              <a:rPr sz="1400" b="1">
+                <a:solidFill>
+                  <a:srgbClr val="DC2626"/>
+                </a:solidFill>
+                <a:latin typeface="Calibri"/>
+              </a:rPr>
+              <a:t>0% Hallucination Rate
+</a:t>
+            </a:r>
+            <a:r>
+              <a:rPr sz="1100">
                 <a:solidFill>
                   <a:srgbClr val="334155"/>
                 </a:solidFill>
                 <a:latin typeface="Calibri"/>
-              </a:defRPr>
-            </a:pPr>
-            <a:r>
-              <a:t>Cuts average enterprise approval cycles from 2.5 days down to sub-minute execution.</a:t>
+              </a:rPr>
+              <a:t>Zero speculation: strictly halts AI from guessing when data is incomplete.</a:t>
             </a:r>
           </a:p>
           <a:p>
             <a:pPr>
               <a:spcAft>
-                <a:spcPts val="200"/>
+                <a:spcPts val="1000"/>
               </a:spcAft>
             </a:pPr>
             <a:r>
-              <a:rPr sz="1300" b="1">
-                <a:solidFill>
-                  <a:srgbClr val="1E293B"/>
+              <a:rPr sz="1400" b="1">
+                <a:solidFill>
+                  <a:srgbClr val="D97706"/>
                 </a:solidFill>
                 <a:latin typeface="Calibri"/>
               </a:rPr>
-              <a:t>🛡️ Zero-Hallucination Guarantee</a:t>
+              <a:t>15s Human Micro-Ask
+</a:t>
+            </a:r>
+            <a:r>
+              <a:rPr sz="1100">
+                <a:solidFill>
+                  <a:srgbClr val="334155"/>
+                </a:solidFill>
+                <a:latin typeface="Calibri"/>
+              </a:rPr>
+              <a:t>Executives never read 40 pages; they answer a 1-click micro-question.</a:t>
             </a:r>
           </a:p>
           <a:p>
             <a:pPr>
               <a:spcAft>
-                <a:spcPts val="1200"/>
-              </a:spcAft>
-              <a:defRPr sz="1200">
-                <a:solidFill>
-                  <a:srgbClr val="334155"/>
-                </a:solidFill>
-                <a:latin typeface="Calibri"/>
-              </a:defRPr>
+                <a:spcPts val="1000"/>
+              </a:spcAft>
             </a:pPr>
             <a:r>
-              <a:t>Hard gate strictly halts AI from guessing or making decisions when evidence is incomplete.</a:t>
-            </a:r>
-          </a:p>
-          <a:p>
-            <a:pPr>
-              <a:spcAft>
-                <a:spcPts val="200"/>
-              </a:spcAft>
-            </a:pPr>
-            <a:r>
-              <a:rPr sz="1300" b="1">
-                <a:solidFill>
-                  <a:srgbClr val="1E293B"/>
+              <a:rPr sz="1400" b="1">
+                <a:solidFill>
+                  <a:srgbClr val="16A34A"/>
                 </a:solidFill>
                 <a:latin typeface="Calibri"/>
               </a:rPr>
-              <a:t>⏱️ 15-Sec Human Overhead</a:t>
-            </a:r>
-          </a:p>
-          <a:p>
-            <a:pPr>
-              <a:spcAft>
-                <a:spcPts val="1200"/>
-              </a:spcAft>
-              <a:defRPr sz="1200">
+              <a:t>88% Autonomous Healing
+</a:t>
+            </a:r>
+            <a:r>
+              <a:rPr sz="1100">
                 <a:solidFill>
                   <a:srgbClr val="334155"/>
-                </a:solidFill>
-                <a:latin typeface="Calibri"/>
-              </a:defRPr>
-            </a:pPr>
-            <a:r>
-              <a:t>Replaces exhausting 40-page document reviews with 1-click targeted micro-approvals.</a:t>
-            </a:r>
-          </a:p>
-          <a:p>
-            <a:pPr>
-              <a:spcAft>
-                <a:spcPts val="200"/>
-              </a:spcAft>
-            </a:pPr>
-            <a:r>
-              <a:rPr sz="1300" b="1">
-                <a:solidFill>
-                  <a:srgbClr val="1E293B"/>
                 </a:solidFill>
                 <a:latin typeface="Calibri"/>
               </a:rPr>
-              <a:t>📈 Process Self-Healing</a:t>
-            </a:r>
-          </a:p>
-          <a:p>
-            <a:pPr>
-              <a:spcAft>
-                <a:spcPts val="1200"/>
-              </a:spcAft>
-              <a:defRPr sz="1200">
-                <a:solidFill>
-                  <a:srgbClr val="334155"/>
-                </a:solidFill>
-                <a:latin typeface="Calibri"/>
-              </a:defRPr>
-            </a:pPr>
-            <a:r>
-              <a:t>Continuous process mining diagnoses systemic blockers to permanently optimize intake forms.</a:t>
+              <a:t>Self-heals gaps by searching Drive, Email, and ERP ledgers.</a:t>
             </a:r>
           </a:p>
         </p:txBody>
@@ -15945,14 +17893,14 @@
           </a:fontRef>
         </p:style>
         <p:txBody>
-          <a:bodyPr rtlCol="0" anchor="t" lIns="274320" rIns="274320" tIns="274320" wrap="square"/>
+          <a:bodyPr rtlCol="0" anchor="ctr" lIns="274320" rIns="274320" tIns="274320" wrap="square"/>
           <a:lstStyle/>
           <a:p>
             <a:pPr algn="ctr">
               <a:spcAft>
                 <a:spcPts val="800"/>
               </a:spcAft>
-              <a:defRPr sz="1600" b="1">
+              <a:defRPr sz="1400" b="1">
                 <a:solidFill>
                   <a:srgbClr val="0F172A"/>
                 </a:solidFill>
@@ -15966,128 +17914,104 @@
           <a:p>
             <a:pPr>
               <a:spcAft>
-                <a:spcPts val="200"/>
+                <a:spcPts val="1000"/>
               </a:spcAft>
             </a:pPr>
             <a:r>
-              <a:rPr sz="1300" b="1">
+              <a:rPr sz="1200" b="1">
                 <a:solidFill>
                   <a:srgbClr val="1E293B"/>
                 </a:solidFill>
                 <a:latin typeface="Calibri"/>
               </a:rPr>
-              <a:t>📦 Importable n8n Workflow</a:t>
+              <a:t>📦 Importable n8n Workflow
+</a:t>
+            </a:r>
+            <a:r>
+              <a:rPr sz="1100">
+                <a:solidFill>
+                  <a:srgbClr val="334155"/>
+                </a:solidFill>
+                <a:latin typeface="Calibri"/>
+              </a:rPr>
+              <a:t>Full production JSON workflow with AI Agent, Tool &amp; Webhook nodes (`decision_completeness_engine.json`).</a:t>
             </a:r>
           </a:p>
           <a:p>
             <a:pPr>
               <a:spcAft>
-                <a:spcPts val="1200"/>
-              </a:spcAft>
-              <a:defRPr sz="1200">
+                <a:spcPts val="1000"/>
+              </a:spcAft>
+            </a:pPr>
+            <a:r>
+              <a:rPr sz="1200" b="1">
+                <a:solidFill>
+                  <a:srgbClr val="1E293B"/>
+                </a:solidFill>
+                <a:latin typeface="Calibri"/>
+              </a:rPr>
+              <a:t>🧪 Automated Test Suite
+</a:t>
+            </a:r>
+            <a:r>
+              <a:rPr sz="1100">
                 <a:solidFill>
                   <a:srgbClr val="334155"/>
                 </a:solidFill>
                 <a:latin typeface="Calibri"/>
-              </a:defRPr>
-            </a:pPr>
-            <a:r>
-              <a:t>Full production JSON workflow with AI Agent, Tool &amp; Webhook nodes (`decision_completeness_engine.json`).</a:t>
+              </a:rPr>
+              <a:t>9/9 passing unit &amp; integration tests (`python -m unittest tests/test_engine.py`).</a:t>
             </a:r>
           </a:p>
           <a:p>
             <a:pPr>
               <a:spcAft>
-                <a:spcPts val="200"/>
+                <a:spcPts val="1000"/>
               </a:spcAft>
             </a:pPr>
             <a:r>
-              <a:rPr sz="1300" b="1">
+              <a:rPr sz="1200" b="1">
                 <a:solidFill>
                   <a:srgbClr val="1E293B"/>
                 </a:solidFill>
                 <a:latin typeface="Calibri"/>
               </a:rPr>
-              <a:t>🧪 Automated Test Suite</a:t>
+              <a:t>☁️ Multi-Cloud Deployment
+</a:t>
+            </a:r>
+            <a:r>
+              <a:rPr sz="1100">
+                <a:solidFill>
+                  <a:srgbClr val="334155"/>
+                </a:solidFill>
+                <a:latin typeface="Calibri"/>
+              </a:rPr>
+              <a:t>Dockerfile, Render (render.yaml), Railway (railway.json), and Vercel configuration ready to deploy.</a:t>
             </a:r>
           </a:p>
           <a:p>
             <a:pPr>
               <a:spcAft>
-                <a:spcPts val="1200"/>
-              </a:spcAft>
-              <a:defRPr sz="1200">
-                <a:solidFill>
-                  <a:srgbClr val="334155"/>
-                </a:solidFill>
-                <a:latin typeface="Calibri"/>
-              </a:defRPr>
+                <a:spcPts val="1000"/>
+              </a:spcAft>
             </a:pPr>
             <a:r>
-              <a:t>9/9 passing unit &amp; integration tests (`python -m unittest tests/test_engine.py`).</a:t>
-            </a:r>
-          </a:p>
-          <a:p>
-            <a:pPr>
-              <a:spcAft>
-                <a:spcPts val="200"/>
-              </a:spcAft>
-            </a:pPr>
-            <a:r>
-              <a:rPr sz="1300" b="1">
+              <a:rPr sz="1200" b="1">
                 <a:solidFill>
                   <a:srgbClr val="1E293B"/>
                 </a:solidFill>
                 <a:latin typeface="Calibri"/>
               </a:rPr>
-              <a:t>☁️ Multi-Cloud Deployment</a:t>
-            </a:r>
-          </a:p>
-          <a:p>
-            <a:pPr>
-              <a:spcAft>
-                <a:spcPts val="1200"/>
-              </a:spcAft>
-              <a:defRPr sz="1200">
+              <a:t>🔒 Cryptographic Audit Proof
+</a:t>
+            </a:r>
+            <a:r>
+              <a:rPr sz="1100">
                 <a:solidFill>
                   <a:srgbClr val="334155"/>
-                </a:solidFill>
-                <a:latin typeface="Calibri"/>
-              </a:defRPr>
-            </a:pPr>
-            <a:r>
-              <a:t>Dockerfile, Render (render.yaml), Railway (railway.json), and Vercel configuration ready to deploy.</a:t>
-            </a:r>
-          </a:p>
-          <a:p>
-            <a:pPr>
-              <a:spcAft>
-                <a:spcPts val="200"/>
-              </a:spcAft>
-            </a:pPr>
-            <a:r>
-              <a:rPr sz="1300" b="1">
-                <a:solidFill>
-                  <a:srgbClr val="1E293B"/>
                 </a:solidFill>
                 <a:latin typeface="Calibri"/>
               </a:rPr>
-              <a:t>🔒 Cryptographic Audit Proof</a:t>
-            </a:r>
-          </a:p>
-          <a:p>
-            <a:pPr>
-              <a:spcAft>
-                <a:spcPts val="1200"/>
-              </a:spcAft>
-              <a:defRPr sz="1200">
-                <a:solidFill>
-                  <a:srgbClr val="334155"/>
-                </a:solidFill>
-                <a:latin typeface="Calibri"/>
-              </a:defRPr>
-            </a:pPr>
-            <a:r>
               <a:t>SHA-256 chain-of-custody evidence hashing for regulatory compliance and audit readiness.</a:t>
             </a:r>
           </a:p>

</xml_diff>

<commit_message>
Add Tunnel Watchdog with auto-reconnect and sync presentations with active live URL
</commit_message>
<xml_diff>
--- a/HackSprint_Decision_Completeness_Engine.pptx
+++ b/HackSprint_Decision_Completeness_Engine.pptx
@@ -12921,7 +12921,7 @@
                 </a:solidFill>
                 <a:latin typeface="Calibri"/>
               </a:rPr>
-              <a:t>https://static-outstanding-palm-clarke.trycloudflare.com</a:t>
+              <a:t>https://interactive-ext-ran-calculators.trycloudflare.com</a:t>
             </a:r>
           </a:p>
         </p:txBody>
@@ -16761,7 +16761,7 @@
                 </a:solidFill>
                 <a:latin typeface="Calibri"/>
               </a:rPr>
-              <a:t>https://static-outstanding-palm-clarke.trycloudflare.com  [⚡ Fast &lt;50ms | 8 Domains | Zero Hallucination]</a:t>
+              <a:t>https://interactive-ext-ran-calculators.trycloudflare.com  [⚡ Fast &lt;50ms | 8 Domains | Zero Hallucination]</a:t>
             </a:r>
           </a:p>
         </p:txBody>
@@ -16859,7 +16859,7 @@
               </a:defRPr>
             </a:pPr>
             <a:r>
-              <a:t>🔴 🟡 🟢   https://static-outstanding-palm-clarke.trycloudflare.com  —  Decision Completeness Engine Visual Studio</a:t>
+              <a:t>🔴 🟡 🟢   https://interactive-ext-ran-calculators.trycloudflare.com  —  Decision Completeness Engine Visual Studio</a:t>
             </a:r>
           </a:p>
         </p:txBody>

</xml_diff>

<commit_message>
Update presentation and static files with permanent GitHub Pages URL
</commit_message>
<xml_diff>
--- a/HackSprint_Decision_Completeness_Engine.pptx
+++ b/HackSprint_Decision_Completeness_Engine.pptx
@@ -12921,7 +12921,7 @@
                 </a:solidFill>
                 <a:latin typeface="Calibri"/>
               </a:rPr>
-              <a:t>https://interactive-ext-ran-calculators.trycloudflare.com</a:t>
+              <a:t>https://manjusha321-art.github.io/decision-completeness-engine/</a:t>
             </a:r>
           </a:p>
         </p:txBody>
@@ -16761,7 +16761,7 @@
                 </a:solidFill>
                 <a:latin typeface="Calibri"/>
               </a:rPr>
-              <a:t>https://interactive-ext-ran-calculators.trycloudflare.com  [⚡ Fast &lt;50ms | 8 Domains | Zero Hallucination]</a:t>
+              <a:t>https://manjusha321-art.github.io/decision-completeness-engine/  [⚡ Fast &lt;50ms | 8 Domains | Zero Hallucination]</a:t>
             </a:r>
           </a:p>
         </p:txBody>
@@ -16859,7 +16859,7 @@
               </a:defRPr>
             </a:pPr>
             <a:r>
-              <a:t>🔴 🟡 🟢   https://interactive-ext-ran-calculators.trycloudflare.com  —  Decision Completeness Engine Visual Studio</a:t>
+              <a:t>🔴 🟡 🟢   https://manjusha321-art.github.io/decision-completeness-engine/  —  Decision Completeness Engine Visual Studio</a:t>
             </a:r>
           </a:p>
         </p:txBody>

</xml_diff>